<commit_message>
chore: update PPTX slides from 2024 to 2026
- Slide 8 (retrieval.py): built-in doc titles updated to 2026
- Slide 16 (Step-by-Step): example output updated to Q2 2026
- Slide 18 (Sample Data): q3_2024 filename updated to q3_2026

Co-Authored-By: Claude Sonnet 4.6 <noreply@anthropic.com>
</commit_message>
<xml_diff>
--- a/Document_Assistant.pptx
+++ b/Document_Assistant.pptx
@@ -12738,7 +12738,7 @@
                 <a:ea typeface="Calibri" pitchFamily="34" charset="-122"/>
                 <a:cs typeface="Calibri" pitchFamily="34" charset="-120"/>
               </a:rPr>
-              <a:t>state["current_response"].result displayed in chat bubble: "The Q2 2024 net profit is $1,900,000."</a:t>
+              <a:t>state["current_response"].result displayed in chat bubble: "The Q2 2026 net profit is $1,900,000."</a:t>
             </a:r>
             <a:endParaRPr lang="en-US" sz="900" dirty="0"/>
           </a:p>
@@ -15077,7 +15077,7 @@
                 <a:ea typeface="Calibri" pitchFamily="34" charset="-122"/>
                 <a:cs typeface="Calibri" pitchFamily="34" charset="-120"/>
               </a:rPr>
-              <a:t>q3_2024_financial_report.csv</a:t>
+              <a:t>q3_2026_financial_report.csv</a:t>
             </a:r>
             <a:endParaRPr lang="en-US" sz="1100" dirty="0"/>
           </a:p>
@@ -24605,7 +24605,7 @@
                 <a:ea typeface="Calibri" pitchFamily="34" charset="-122"/>
                 <a:cs typeface="Calibri" pitchFamily="34" charset="-120"/>
               </a:rPr>
-              <a:t>Q1 2024 Financial Report</a:t>
+              <a:t>Q1 2026 Financial Report</a:t>
             </a:r>
             <a:endParaRPr lang="en-US" sz="950" dirty="0"/>
           </a:p>
@@ -24710,7 +24710,7 @@
                 <a:ea typeface="Calibri" pitchFamily="34" charset="-122"/>
                 <a:cs typeface="Calibri" pitchFamily="34" charset="-120"/>
               </a:rPr>
-              <a:t>Q2 2024 Financial Report</a:t>
+              <a:t>Q2 2026 Financial Report</a:t>
             </a:r>
             <a:endParaRPr lang="en-US" sz="950" dirty="0"/>
           </a:p>
@@ -24815,7 +24815,7 @@
                 <a:ea typeface="Calibri" pitchFamily="34" charset="-122"/>
                 <a:cs typeface="Calibri" pitchFamily="34" charset="-120"/>
               </a:rPr>
-              <a:t>Healthcare Statistics 2024</a:t>
+              <a:t>Healthcare Statistics 2026</a:t>
             </a:r>
             <a:endParaRPr lang="en-US" sz="950" dirty="0"/>
           </a:p>
@@ -24920,7 +24920,7 @@
                 <a:ea typeface="Calibri" pitchFamily="34" charset="-122"/>
                 <a:cs typeface="Calibri" pitchFamily="34" charset="-120"/>
               </a:rPr>
-              <a:t>Patient Outcomes Report 2024</a:t>
+              <a:t>Patient Outcomes Report 2026</a:t>
             </a:r>
             <a:endParaRPr lang="en-US" sz="950" dirty="0"/>
           </a:p>

</xml_diff>

<commit_message>
docs: add 8 update slides to PPTX (slides 21-28)
Slide 21: Section divider — Recent Updates Oct 2026
Slide 22: Numbered menu CLI (options 1-6) with repeat-or-back sub-menu
Slide 23: tkinter native file picker for Upload
Slide 24: Per-session log files (logs/<session_id>.log)
Slide 25: Full conversation history in sessions/<uuid>.json
Slide 26: MessagesPlaceholder added to all ChatPromptTemplates
Slide 27: Enriched intent classification prompt (examples, confidence guide, tie-breaking)
Slide 28: Summary table of all 8 updates

Co-Authored-By: Claude Sonnet 4.6 <noreply@anthropic.com>
</commit_message>
<xml_diff>
--- a/Document_Assistant.pptx
+++ b/Document_Assistant.pptx
@@ -25,6 +25,14 @@
     <p:sldId id="273" r:id="rId19"/>
     <p:sldId id="274" r:id="rId20"/>
     <p:sldId id="275" r:id="rId21"/>
+    <p:sldId id="276" r:id="rId27"/>
+    <p:sldId id="277" r:id="rId28"/>
+    <p:sldId id="278" r:id="rId29"/>
+    <p:sldId id="279" r:id="rId30"/>
+    <p:sldId id="280" r:id="rId31"/>
+    <p:sldId id="281" r:id="rId32"/>
+    <p:sldId id="282" r:id="rId33"/>
+    <p:sldId id="283" r:id="rId34"/>
   </p:sldIdLst>
   <p:notesMasterIdLst>
     <p:notesMasterId r:id="rId22"/>
@@ -17732,6 +17740,3694 @@
 </p:sld>
 </file>
 
+<file path=ppt/slides/slide21.xml><?xml version="1.0" encoding="utf-8"?>
+<p:sld xmlns:a="http://schemas.openxmlformats.org/drawingml/2006/main" xmlns:p="http://schemas.openxmlformats.org/presentationml/2006/main" xmlns:r="http://schemas.openxmlformats.org/officeDocument/2006/relationships">
+  <p:cSld>
+    <p:bg>
+      <p:bgPr>
+        <a:solidFill>
+          <a:srgbClr val="1E1E2E"/>
+        </a:solidFill>
+        <a:effectLst/>
+      </p:bgPr>
+    </p:bg>
+    <p:spTree>
+      <p:nvGrpSpPr>
+        <p:cNvPr id="1" name=""/>
+        <p:cNvGrpSpPr/>
+        <p:nvPr/>
+      </p:nvGrpSpPr>
+      <p:grpSpPr/>
+      <p:sp>
+        <p:nvSpPr>
+          <p:cNvPr id="2" name="TextBox 1"/>
+          <p:cNvSpPr txBox="1"/>
+          <p:nvPr/>
+        </p:nvSpPr>
+        <p:spPr>
+          <a:xfrm>
+            <a:off x="914400" y="2286000"/>
+            <a:ext cx="7315200" cy="1097280"/>
+          </a:xfrm>
+          <a:prstGeom prst="rect">
+            <a:avLst/>
+          </a:prstGeom>
+          <a:noFill/>
+        </p:spPr>
+        <p:txBody>
+          <a:bodyPr wrap="none">
+            <a:spAutoFit/>
+          </a:bodyPr>
+          <a:lstStyle/>
+          <a:p>
+            <a:pPr algn="ctr"/>
+            <a:r>
+              <a:rPr b="1" sz="3200">
+                <a:solidFill>
+                  <a:srgbClr val="74C7EC"/>
+                </a:solidFill>
+              </a:rPr>
+              <a:t>Recent Updates — Oct 2026</a:t>
+            </a:r>
+          </a:p>
+        </p:txBody>
+      </p:sp>
+      <p:sp>
+        <p:nvSpPr>
+          <p:cNvPr id="3" name="TextBox 2"/>
+          <p:cNvSpPr txBox="1"/>
+          <p:nvPr/>
+        </p:nvSpPr>
+        <p:spPr>
+          <a:xfrm>
+            <a:off x="914400" y="3474720"/>
+            <a:ext cx="7315200" cy="640080"/>
+          </a:xfrm>
+          <a:prstGeom prst="rect">
+            <a:avLst/>
+          </a:prstGeom>
+          <a:noFill/>
+        </p:spPr>
+        <p:txBody>
+          <a:bodyPr wrap="none">
+            <a:spAutoFit/>
+          </a:bodyPr>
+          <a:lstStyle/>
+          <a:p>
+            <a:pPr algn="ctr"/>
+            <a:r>
+              <a:rPr sz="1600">
+                <a:solidFill>
+                  <a:srgbClr val="CDD6F4"/>
+                </a:solidFill>
+              </a:rPr>
+              <a:t>CLI  ·  Logging  ·  Sessions  ·  Prompt Engineering</a:t>
+            </a:r>
+          </a:p>
+        </p:txBody>
+      </p:sp>
+    </p:spTree>
+  </p:cSld>
+  <p:clrMapOvr>
+    <a:masterClrMapping/>
+  </p:clrMapOvr>
+</p:sld>
+</file>
+
+<file path=ppt/slides/slide22.xml><?xml version="1.0" encoding="utf-8"?>
+<p:sld xmlns:a="http://schemas.openxmlformats.org/drawingml/2006/main" xmlns:p="http://schemas.openxmlformats.org/presentationml/2006/main" xmlns:r="http://schemas.openxmlformats.org/officeDocument/2006/relationships">
+  <p:cSld>
+    <p:bg>
+      <p:bgPr>
+        <a:solidFill>
+          <a:srgbClr val="1E1E2E"/>
+        </a:solidFill>
+        <a:effectLst/>
+      </p:bgPr>
+    </p:bg>
+    <p:spTree>
+      <p:nvGrpSpPr>
+        <p:cNvPr id="1" name=""/>
+        <p:cNvGrpSpPr/>
+        <p:nvPr/>
+      </p:nvGrpSpPr>
+      <p:grpSpPr/>
+      <p:sp>
+        <p:nvSpPr>
+          <p:cNvPr id="2" name="TextBox 1"/>
+          <p:cNvSpPr txBox="1"/>
+          <p:nvPr/>
+        </p:nvSpPr>
+        <p:spPr>
+          <a:xfrm>
+            <a:off x="365760" y="228600"/>
+            <a:ext cx="8412480" cy="594360"/>
+          </a:xfrm>
+          <a:prstGeom prst="rect">
+            <a:avLst/>
+          </a:prstGeom>
+          <a:noFill/>
+        </p:spPr>
+        <p:txBody>
+          <a:bodyPr wrap="none">
+            <a:spAutoFit/>
+          </a:bodyPr>
+          <a:lstStyle/>
+          <a:p>
+            <a:pPr algn="l"/>
+            <a:r>
+              <a:rPr b="1" sz="2400">
+                <a:solidFill>
+                  <a:srgbClr val="74C7EC"/>
+                </a:solidFill>
+              </a:rPr>
+              <a:t>Update 1 — Numbered Menu CLI (main.py)</a:t>
+            </a:r>
+          </a:p>
+        </p:txBody>
+      </p:sp>
+      <p:sp>
+        <p:nvSpPr>
+          <p:cNvPr id="3" name="TextBox 2"/>
+          <p:cNvSpPr txBox="1"/>
+          <p:nvPr/>
+        </p:nvSpPr>
+        <p:spPr>
+          <a:xfrm>
+            <a:off x="365760" y="914400"/>
+            <a:ext cx="8412480" cy="640080"/>
+          </a:xfrm>
+          <a:prstGeom prst="rect">
+            <a:avLst/>
+          </a:prstGeom>
+          <a:noFill/>
+        </p:spPr>
+        <p:txBody>
+          <a:bodyPr wrap="square">
+            <a:spAutoFit/>
+          </a:bodyPr>
+          <a:lstStyle/>
+          <a:p>
+            <a:pPr algn="l"/>
+            <a:r>
+              <a:rPr sz="1300" b="0">
+                <a:solidFill>
+                  <a:srgbClr val="CDD6F4"/>
+                </a:solidFill>
+              </a:rPr>
+              <a:t>Replaced free-text command input with a numbered menu.</a:t>
+            </a:r>
+          </a:p>
+          <a:p>
+            <a:pPr algn="l"/>
+            <a:r>
+              <a:rPr sz="1300" b="0">
+                <a:solidFill>
+                  <a:srgbClr val="CDD6F4"/>
+                </a:solidFill>
+              </a:rPr>
+              <a:t>Every option shows a repeat-or-back sub-menu after each action.</a:t>
+            </a:r>
+          </a:p>
+          <a:p>
+            <a:pPr algn="l"/>
+            <a:r>
+              <a:rPr sz="1300" b="0">
+                <a:solidFill>
+                  <a:srgbClr val="CDD6F4"/>
+                </a:solidFill>
+              </a:rPr>
+              <a:t/>
+            </a:r>
+          </a:p>
+        </p:txBody>
+      </p:sp>
+      <p:sp>
+        <p:nvSpPr>
+          <p:cNvPr id="4" name="Rectangle 3"/>
+          <p:cNvSpPr/>
+          <p:nvPr/>
+        </p:nvSpPr>
+        <p:spPr>
+          <a:xfrm>
+            <a:off x="365760" y="1691640"/>
+            <a:ext cx="8412480" cy="4206240"/>
+          </a:xfrm>
+          <a:prstGeom prst="rect">
+            <a:avLst/>
+          </a:prstGeom>
+          <a:solidFill>
+            <a:srgbClr val="18182E"/>
+          </a:solidFill>
+          <a:ln>
+            <a:noFill/>
+          </a:ln>
+        </p:spPr>
+        <p:style>
+          <a:lnRef idx="1">
+            <a:schemeClr val="accent1"/>
+          </a:lnRef>
+          <a:fillRef idx="3">
+            <a:schemeClr val="accent1"/>
+          </a:fillRef>
+          <a:effectRef idx="2">
+            <a:schemeClr val="accent1"/>
+          </a:effectRef>
+          <a:fontRef idx="minor">
+            <a:schemeClr val="lt1"/>
+          </a:fontRef>
+        </p:style>
+        <p:txBody>
+          <a:bodyPr rtlCol="0" anchor="ctr"/>
+          <a:lstStyle/>
+          <a:p>
+            <a:pPr algn="ctr"/>
+          </a:p>
+        </p:txBody>
+      </p:sp>
+      <p:sp>
+        <p:nvSpPr>
+          <p:cNvPr id="5" name="TextBox 4"/>
+          <p:cNvSpPr txBox="1"/>
+          <p:nvPr/>
+        </p:nvSpPr>
+        <p:spPr>
+          <a:xfrm>
+            <a:off x="457200" y="1783080"/>
+            <a:ext cx="8229600" cy="4023360"/>
+          </a:xfrm>
+          <a:prstGeom prst="rect">
+            <a:avLst/>
+          </a:prstGeom>
+          <a:noFill/>
+        </p:spPr>
+        <p:txBody>
+          <a:bodyPr wrap="square">
+            <a:spAutoFit/>
+          </a:bodyPr>
+          <a:lstStyle/>
+          <a:p>
+            <a:r>
+              <a:rPr sz="1100">
+                <a:solidFill>
+                  <a:srgbClr val="A6E3A1"/>
+                </a:solidFill>
+                <a:latin typeface="Courier New"/>
+              </a:rPr>
+              <a:t>  ┌─────────────────────────────────────────┐</a:t>
+            </a:r>
+          </a:p>
+          <a:p>
+            <a:r>
+              <a:rPr sz="1100">
+                <a:solidFill>
+                  <a:srgbClr val="A6E3A1"/>
+                </a:solidFill>
+                <a:latin typeface="Courier New"/>
+              </a:rPr>
+              <a:t>  │  1  📁  Upload Document                 │</a:t>
+            </a:r>
+          </a:p>
+          <a:p>
+            <a:r>
+              <a:rPr sz="1100">
+                <a:solidFill>
+                  <a:srgbClr val="A6E3A1"/>
+                </a:solidFill>
+                <a:latin typeface="Courier New"/>
+              </a:rPr>
+              <a:t>  │  2  ❓  Question &amp; Answer               │</a:t>
+            </a:r>
+          </a:p>
+          <a:p>
+            <a:r>
+              <a:rPr sz="1100">
+                <a:solidFill>
+                  <a:srgbClr val="A6E3A1"/>
+                </a:solidFill>
+                <a:latin typeface="Courier New"/>
+              </a:rPr>
+              <a:t>  │  3  📄  Summarize Document              │</a:t>
+            </a:r>
+          </a:p>
+          <a:p>
+            <a:r>
+              <a:rPr sz="1100">
+                <a:solidFill>
+                  <a:srgbClr val="A6E3A1"/>
+                </a:solidFill>
+                <a:latin typeface="Courier New"/>
+              </a:rPr>
+              <a:t>  │  4  🧮  Calculator                      │</a:t>
+            </a:r>
+          </a:p>
+          <a:p>
+            <a:r>
+              <a:rPr sz="1100">
+                <a:solidFill>
+                  <a:srgbClr val="A6E3A1"/>
+                </a:solidFill>
+                <a:latin typeface="Courier New"/>
+              </a:rPr>
+              <a:t>  │  5  📚  Show Loaded Documents           │</a:t>
+            </a:r>
+          </a:p>
+          <a:p>
+            <a:r>
+              <a:rPr sz="1100">
+                <a:solidFill>
+                  <a:srgbClr val="A6E3A1"/>
+                </a:solidFill>
+                <a:latin typeface="Courier New"/>
+              </a:rPr>
+              <a:t>  │  6  ℹ️   Session Info                   │</a:t>
+            </a:r>
+          </a:p>
+          <a:p>
+            <a:r>
+              <a:rPr sz="1100">
+                <a:solidFill>
+                  <a:srgbClr val="A6E3A1"/>
+                </a:solidFill>
+                <a:latin typeface="Courier New"/>
+              </a:rPr>
+              <a:t>  │  0  ❌  Quit                            │</a:t>
+            </a:r>
+          </a:p>
+          <a:p>
+            <a:r>
+              <a:rPr sz="1100">
+                <a:solidFill>
+                  <a:srgbClr val="A6E3A1"/>
+                </a:solidFill>
+                <a:latin typeface="Courier New"/>
+              </a:rPr>
+              <a:t>  └─────────────────────────────────────────┘</a:t>
+            </a:r>
+          </a:p>
+          <a:p>
+            <a:r>
+              <a:rPr sz="1100">
+                <a:solidFill>
+                  <a:srgbClr val="A6E3A1"/>
+                </a:solidFill>
+                <a:latin typeface="Courier New"/>
+              </a:rPr>
+              <a:t/>
+            </a:r>
+          </a:p>
+          <a:p>
+            <a:r>
+              <a:rPr sz="1100">
+                <a:solidFill>
+                  <a:srgbClr val="A6E3A1"/>
+                </a:solidFill>
+                <a:latin typeface="Courier New"/>
+              </a:rPr>
+              <a:t>  After each action:</a:t>
+            </a:r>
+          </a:p>
+          <a:p>
+            <a:r>
+              <a:rPr sz="1100">
+                <a:solidFill>
+                  <a:srgbClr val="A6E3A1"/>
+                </a:solidFill>
+                <a:latin typeface="Courier New"/>
+              </a:rPr>
+              <a:t>  ┌──────────────────────────────────────────┐</a:t>
+            </a:r>
+          </a:p>
+          <a:p>
+            <a:r>
+              <a:rPr sz="1100">
+                <a:solidFill>
+                  <a:srgbClr val="A6E3A1"/>
+                </a:solidFill>
+                <a:latin typeface="Courier New"/>
+              </a:rPr>
+              <a:t>  │  1  🔄  Ask another question             │</a:t>
+            </a:r>
+          </a:p>
+          <a:p>
+            <a:r>
+              <a:rPr sz="1100">
+                <a:solidFill>
+                  <a:srgbClr val="A6E3A1"/>
+                </a:solidFill>
+                <a:latin typeface="Courier New"/>
+              </a:rPr>
+              <a:t>  │  0  ↩   Back to main menu                │</a:t>
+            </a:r>
+          </a:p>
+          <a:p>
+            <a:r>
+              <a:rPr sz="1100">
+                <a:solidFill>
+                  <a:srgbClr val="A6E3A1"/>
+                </a:solidFill>
+                <a:latin typeface="Courier New"/>
+              </a:rPr>
+              <a:t>  └──────────────────────────────────────────┘</a:t>
+            </a:r>
+          </a:p>
+        </p:txBody>
+      </p:sp>
+    </p:spTree>
+  </p:cSld>
+  <p:clrMapOvr>
+    <a:masterClrMapping/>
+  </p:clrMapOvr>
+</p:sld>
+</file>
+
+<file path=ppt/slides/slide23.xml><?xml version="1.0" encoding="utf-8"?>
+<p:sld xmlns:a="http://schemas.openxmlformats.org/drawingml/2006/main" xmlns:p="http://schemas.openxmlformats.org/presentationml/2006/main" xmlns:r="http://schemas.openxmlformats.org/officeDocument/2006/relationships">
+  <p:cSld>
+    <p:bg>
+      <p:bgPr>
+        <a:solidFill>
+          <a:srgbClr val="1E1E2E"/>
+        </a:solidFill>
+        <a:effectLst/>
+      </p:bgPr>
+    </p:bg>
+    <p:spTree>
+      <p:nvGrpSpPr>
+        <p:cNvPr id="1" name=""/>
+        <p:cNvGrpSpPr/>
+        <p:nvPr/>
+      </p:nvGrpSpPr>
+      <p:grpSpPr/>
+      <p:sp>
+        <p:nvSpPr>
+          <p:cNvPr id="2" name="TextBox 1"/>
+          <p:cNvSpPr txBox="1"/>
+          <p:nvPr/>
+        </p:nvSpPr>
+        <p:spPr>
+          <a:xfrm>
+            <a:off x="365760" y="228600"/>
+            <a:ext cx="8412480" cy="594360"/>
+          </a:xfrm>
+          <a:prstGeom prst="rect">
+            <a:avLst/>
+          </a:prstGeom>
+          <a:noFill/>
+        </p:spPr>
+        <p:txBody>
+          <a:bodyPr wrap="none">
+            <a:spAutoFit/>
+          </a:bodyPr>
+          <a:lstStyle/>
+          <a:p>
+            <a:pPr algn="l"/>
+            <a:r>
+              <a:rPr b="1" sz="2400">
+                <a:solidFill>
+                  <a:srgbClr val="74C7EC"/>
+                </a:solidFill>
+              </a:rPr>
+              <a:t>Update 2 — Native File Picker (tkinter)</a:t>
+            </a:r>
+          </a:p>
+        </p:txBody>
+      </p:sp>
+      <p:sp>
+        <p:nvSpPr>
+          <p:cNvPr id="3" name="TextBox 2"/>
+          <p:cNvSpPr txBox="1"/>
+          <p:nvPr/>
+        </p:nvSpPr>
+        <p:spPr>
+          <a:xfrm>
+            <a:off x="365760" y="914400"/>
+            <a:ext cx="8412480" cy="822960"/>
+          </a:xfrm>
+          <a:prstGeom prst="rect">
+            <a:avLst/>
+          </a:prstGeom>
+          <a:noFill/>
+        </p:spPr>
+        <p:txBody>
+          <a:bodyPr wrap="square">
+            <a:spAutoFit/>
+          </a:bodyPr>
+          <a:lstStyle/>
+          <a:p>
+            <a:pPr algn="l"/>
+            <a:r>
+              <a:rPr sz="1300" b="0">
+                <a:solidFill>
+                  <a:srgbClr val="CDD6F4"/>
+                </a:solidFill>
+              </a:rPr>
+              <a:t>Option 1 opens a native Windows file browser dialog via tkinter.filedialog.</a:t>
+            </a:r>
+          </a:p>
+          <a:p>
+            <a:pPr algn="l"/>
+            <a:r>
+              <a:rPr sz="1300" b="0">
+                <a:solidFill>
+                  <a:srgbClr val="CDD6F4"/>
+                </a:solidFill>
+              </a:rPr>
+              <a:t>Falls back to manual path entry if dialog is unavailable.</a:t>
+            </a:r>
+          </a:p>
+          <a:p>
+            <a:pPr algn="l"/>
+            <a:r>
+              <a:rPr sz="1300" b="0">
+                <a:solidFill>
+                  <a:srgbClr val="CDD6F4"/>
+                </a:solidFill>
+              </a:rPr>
+              <a:t>Supports: PDF  TXT  MD  CSV</a:t>
+            </a:r>
+          </a:p>
+        </p:txBody>
+      </p:sp>
+      <p:sp>
+        <p:nvSpPr>
+          <p:cNvPr id="4" name="Rectangle 3"/>
+          <p:cNvSpPr/>
+          <p:nvPr/>
+        </p:nvSpPr>
+        <p:spPr>
+          <a:xfrm>
+            <a:off x="365760" y="1828800"/>
+            <a:ext cx="8412480" cy="4023360"/>
+          </a:xfrm>
+          <a:prstGeom prst="rect">
+            <a:avLst/>
+          </a:prstGeom>
+          <a:solidFill>
+            <a:srgbClr val="18182E"/>
+          </a:solidFill>
+          <a:ln>
+            <a:noFill/>
+          </a:ln>
+        </p:spPr>
+        <p:style>
+          <a:lnRef idx="1">
+            <a:schemeClr val="accent1"/>
+          </a:lnRef>
+          <a:fillRef idx="3">
+            <a:schemeClr val="accent1"/>
+          </a:fillRef>
+          <a:effectRef idx="2">
+            <a:schemeClr val="accent1"/>
+          </a:effectRef>
+          <a:fontRef idx="minor">
+            <a:schemeClr val="lt1"/>
+          </a:fontRef>
+        </p:style>
+        <p:txBody>
+          <a:bodyPr rtlCol="0" anchor="ctr"/>
+          <a:lstStyle/>
+          <a:p>
+            <a:pPr algn="ctr"/>
+          </a:p>
+        </p:txBody>
+      </p:sp>
+      <p:sp>
+        <p:nvSpPr>
+          <p:cNvPr id="5" name="TextBox 4"/>
+          <p:cNvSpPr txBox="1"/>
+          <p:nvPr/>
+        </p:nvSpPr>
+        <p:spPr>
+          <a:xfrm>
+            <a:off x="457200" y="1920240"/>
+            <a:ext cx="8229600" cy="3840480"/>
+          </a:xfrm>
+          <a:prstGeom prst="rect">
+            <a:avLst/>
+          </a:prstGeom>
+          <a:noFill/>
+        </p:spPr>
+        <p:txBody>
+          <a:bodyPr wrap="square">
+            <a:spAutoFit/>
+          </a:bodyPr>
+          <a:lstStyle/>
+          <a:p>
+            <a:r>
+              <a:rPr sz="1100">
+                <a:solidFill>
+                  <a:srgbClr val="A6E3A1"/>
+                </a:solidFill>
+                <a:latin typeface="Courier New"/>
+              </a:rPr>
+              <a:t>def _pick_file() -&gt; str | None:</a:t>
+            </a:r>
+          </a:p>
+          <a:p>
+            <a:r>
+              <a:rPr sz="1100">
+                <a:solidFill>
+                  <a:srgbClr val="A6E3A1"/>
+                </a:solidFill>
+                <a:latin typeface="Courier New"/>
+              </a:rPr>
+              <a:t>    import tkinter as tk</a:t>
+            </a:r>
+          </a:p>
+          <a:p>
+            <a:r>
+              <a:rPr sz="1100">
+                <a:solidFill>
+                  <a:srgbClr val="A6E3A1"/>
+                </a:solidFill>
+                <a:latin typeface="Courier New"/>
+              </a:rPr>
+              <a:t>    from tkinter import filedialog</a:t>
+            </a:r>
+          </a:p>
+          <a:p>
+            <a:r>
+              <a:rPr sz="1100">
+                <a:solidFill>
+                  <a:srgbClr val="A6E3A1"/>
+                </a:solidFill>
+                <a:latin typeface="Courier New"/>
+              </a:rPr>
+              <a:t>    root = tk.Tk()</a:t>
+            </a:r>
+          </a:p>
+          <a:p>
+            <a:r>
+              <a:rPr sz="1100">
+                <a:solidFill>
+                  <a:srgbClr val="A6E3A1"/>
+                </a:solidFill>
+                <a:latin typeface="Courier New"/>
+              </a:rPr>
+              <a:t>    root.withdraw()               # hide blank Tk window</a:t>
+            </a:r>
+          </a:p>
+          <a:p>
+            <a:r>
+              <a:rPr sz="1100">
+                <a:solidFill>
+                  <a:srgbClr val="A6E3A1"/>
+                </a:solidFill>
+                <a:latin typeface="Courier New"/>
+              </a:rPr>
+              <a:t>    root.attributes("-topmost", True)</a:t>
+            </a:r>
+          </a:p>
+          <a:p>
+            <a:r>
+              <a:rPr sz="1100">
+                <a:solidFill>
+                  <a:srgbClr val="A6E3A1"/>
+                </a:solidFill>
+                <a:latin typeface="Courier New"/>
+              </a:rPr>
+              <a:t>    path = filedialog.askopenfilename(</a:t>
+            </a:r>
+          </a:p>
+          <a:p>
+            <a:r>
+              <a:rPr sz="1100">
+                <a:solidFill>
+                  <a:srgbClr val="A6E3A1"/>
+                </a:solidFill>
+                <a:latin typeface="Courier New"/>
+              </a:rPr>
+              <a:t>        title="Select a document to upload",</a:t>
+            </a:r>
+          </a:p>
+          <a:p>
+            <a:r>
+              <a:rPr sz="1100">
+                <a:solidFill>
+                  <a:srgbClr val="A6E3A1"/>
+                </a:solidFill>
+                <a:latin typeface="Courier New"/>
+              </a:rPr>
+              <a:t>        filetypes=[</a:t>
+            </a:r>
+          </a:p>
+          <a:p>
+            <a:r>
+              <a:rPr sz="1100">
+                <a:solidFill>
+                  <a:srgbClr val="A6E3A1"/>
+                </a:solidFill>
+                <a:latin typeface="Courier New"/>
+              </a:rPr>
+              <a:t>            ("Supported files", "*.pdf *.txt *.md *.csv"),</a:t>
+            </a:r>
+          </a:p>
+          <a:p>
+            <a:r>
+              <a:rPr sz="1100">
+                <a:solidFill>
+                  <a:srgbClr val="A6E3A1"/>
+                </a:solidFill>
+                <a:latin typeface="Courier New"/>
+              </a:rPr>
+              <a:t>            ("All files", "*.*"),</a:t>
+            </a:r>
+          </a:p>
+          <a:p>
+            <a:r>
+              <a:rPr sz="1100">
+                <a:solidFill>
+                  <a:srgbClr val="A6E3A1"/>
+                </a:solidFill>
+                <a:latin typeface="Courier New"/>
+              </a:rPr>
+              <a:t>        ],</a:t>
+            </a:r>
+          </a:p>
+          <a:p>
+            <a:r>
+              <a:rPr sz="1100">
+                <a:solidFill>
+                  <a:srgbClr val="A6E3A1"/>
+                </a:solidFill>
+                <a:latin typeface="Courier New"/>
+              </a:rPr>
+              <a:t>    )</a:t>
+            </a:r>
+          </a:p>
+          <a:p>
+            <a:r>
+              <a:rPr sz="1100">
+                <a:solidFill>
+                  <a:srgbClr val="A6E3A1"/>
+                </a:solidFill>
+                <a:latin typeface="Courier New"/>
+              </a:rPr>
+              <a:t>    root.destroy()</a:t>
+            </a:r>
+          </a:p>
+          <a:p>
+            <a:r>
+              <a:rPr sz="1100">
+                <a:solidFill>
+                  <a:srgbClr val="A6E3A1"/>
+                </a:solidFill>
+                <a:latin typeface="Courier New"/>
+              </a:rPr>
+              <a:t>    return path if path else None</a:t>
+            </a:r>
+          </a:p>
+          <a:p>
+            <a:r>
+              <a:rPr sz="1100">
+                <a:solidFill>
+                  <a:srgbClr val="A6E3A1"/>
+                </a:solidFill>
+                <a:latin typeface="Courier New"/>
+              </a:rPr>
+              <a:t/>
+            </a:r>
+          </a:p>
+          <a:p>
+            <a:r>
+              <a:rPr sz="1100">
+                <a:solidFill>
+                  <a:srgbClr val="A6E3A1"/>
+                </a:solidFill>
+                <a:latin typeface="Courier New"/>
+              </a:rPr>
+              <a:t># Fallback if dialog unavailable:</a:t>
+            </a:r>
+          </a:p>
+          <a:p>
+            <a:r>
+              <a:rPr sz="1100">
+                <a:solidFill>
+                  <a:srgbClr val="A6E3A1"/>
+                </a:solidFill>
+                <a:latin typeface="Courier New"/>
+              </a:rPr>
+              <a:t>file_path = input("  Path: ").strip()</a:t>
+            </a:r>
+          </a:p>
+        </p:txBody>
+      </p:sp>
+    </p:spTree>
+  </p:cSld>
+  <p:clrMapOvr>
+    <a:masterClrMapping/>
+  </p:clrMapOvr>
+</p:sld>
+</file>
+
+<file path=ppt/slides/slide24.xml><?xml version="1.0" encoding="utf-8"?>
+<p:sld xmlns:a="http://schemas.openxmlformats.org/drawingml/2006/main" xmlns:p="http://schemas.openxmlformats.org/presentationml/2006/main" xmlns:r="http://schemas.openxmlformats.org/officeDocument/2006/relationships">
+  <p:cSld>
+    <p:bg>
+      <p:bgPr>
+        <a:solidFill>
+          <a:srgbClr val="1E1E2E"/>
+        </a:solidFill>
+        <a:effectLst/>
+      </p:bgPr>
+    </p:bg>
+    <p:spTree>
+      <p:nvGrpSpPr>
+        <p:cNvPr id="1" name=""/>
+        <p:cNvGrpSpPr/>
+        <p:nvPr/>
+      </p:nvGrpSpPr>
+      <p:grpSpPr/>
+      <p:sp>
+        <p:nvSpPr>
+          <p:cNvPr id="2" name="TextBox 1"/>
+          <p:cNvSpPr txBox="1"/>
+          <p:nvPr/>
+        </p:nvSpPr>
+        <p:spPr>
+          <a:xfrm>
+            <a:off x="365760" y="228600"/>
+            <a:ext cx="8412480" cy="594360"/>
+          </a:xfrm>
+          <a:prstGeom prst="rect">
+            <a:avLst/>
+          </a:prstGeom>
+          <a:noFill/>
+        </p:spPr>
+        <p:txBody>
+          <a:bodyPr wrap="none">
+            <a:spAutoFit/>
+          </a:bodyPr>
+          <a:lstStyle/>
+          <a:p>
+            <a:pPr algn="l"/>
+            <a:r>
+              <a:rPr b="1" sz="2400">
+                <a:solidFill>
+                  <a:srgbClr val="74C7EC"/>
+                </a:solidFill>
+              </a:rPr>
+              <a:t>Update 3 — Per-Session Logs (tools.py)</a:t>
+            </a:r>
+          </a:p>
+        </p:txBody>
+      </p:sp>
+      <p:sp>
+        <p:nvSpPr>
+          <p:cNvPr id="3" name="TextBox 2"/>
+          <p:cNvSpPr txBox="1"/>
+          <p:nvPr/>
+        </p:nvSpPr>
+        <p:spPr>
+          <a:xfrm>
+            <a:off x="365760" y="914400"/>
+            <a:ext cx="8412480" cy="1005840"/>
+          </a:xfrm>
+          <a:prstGeom prst="rect">
+            <a:avLst/>
+          </a:prstGeom>
+          <a:noFill/>
+        </p:spPr>
+        <p:txBody>
+          <a:bodyPr wrap="square">
+            <a:spAutoFit/>
+          </a:bodyPr>
+          <a:lstStyle/>
+          <a:p>
+            <a:pPr algn="l"/>
+            <a:r>
+              <a:rPr sz="1300" b="0">
+                <a:solidFill>
+                  <a:srgbClr val="CDD6F4"/>
+                </a:solidFill>
+              </a:rPr>
+              <a:t>OLD: One file per day  →  logs/tool_calls_2026-10-05.log  (no session ID)</a:t>
+            </a:r>
+          </a:p>
+          <a:p>
+            <a:pPr algn="l"/>
+            <a:r>
+              <a:rPr sz="1300" b="0">
+                <a:solidFill>
+                  <a:srgbClr val="CDD6F4"/>
+                </a:solidFill>
+              </a:rPr>
+              <a:t>NEW: One file per session  →  logs/&lt;session_id&gt;.log</a:t>
+            </a:r>
+          </a:p>
+          <a:p>
+            <a:pPr algn="l"/>
+            <a:r>
+              <a:rPr sz="1300" b="0">
+                <a:solidFill>
+                  <a:srgbClr val="CDD6F4"/>
+                </a:solidFill>
+              </a:rPr>
+              <a:t/>
+            </a:r>
+          </a:p>
+          <a:p>
+            <a:pPr algn="l"/>
+            <a:r>
+              <a:rPr sz="1300" b="0">
+                <a:solidFill>
+                  <a:srgbClr val="CDD6F4"/>
+                </a:solidFill>
+              </a:rPr>
+              <a:t>All code paths now logged with status labels:</a:t>
+            </a:r>
+          </a:p>
+        </p:txBody>
+      </p:sp>
+      <p:sp>
+        <p:nvSpPr>
+          <p:cNvPr id="4" name="Rectangle 3"/>
+          <p:cNvSpPr/>
+          <p:nvPr/>
+        </p:nvSpPr>
+        <p:spPr>
+          <a:xfrm>
+            <a:off x="365760" y="2011680"/>
+            <a:ext cx="8412480" cy="3840480"/>
+          </a:xfrm>
+          <a:prstGeom prst="rect">
+            <a:avLst/>
+          </a:prstGeom>
+          <a:solidFill>
+            <a:srgbClr val="18182E"/>
+          </a:solidFill>
+          <a:ln>
+            <a:noFill/>
+          </a:ln>
+        </p:spPr>
+        <p:style>
+          <a:lnRef idx="1">
+            <a:schemeClr val="accent1"/>
+          </a:lnRef>
+          <a:fillRef idx="3">
+            <a:schemeClr val="accent1"/>
+          </a:fillRef>
+          <a:effectRef idx="2">
+            <a:schemeClr val="accent1"/>
+          </a:effectRef>
+          <a:fontRef idx="minor">
+            <a:schemeClr val="lt1"/>
+          </a:fontRef>
+        </p:style>
+        <p:txBody>
+          <a:bodyPr rtlCol="0" anchor="ctr"/>
+          <a:lstStyle/>
+          <a:p>
+            <a:pPr algn="ctr"/>
+          </a:p>
+        </p:txBody>
+      </p:sp>
+      <p:sp>
+        <p:nvSpPr>
+          <p:cNvPr id="5" name="TextBox 4"/>
+          <p:cNvSpPr txBox="1"/>
+          <p:nvPr/>
+        </p:nvSpPr>
+        <p:spPr>
+          <a:xfrm>
+            <a:off x="457200" y="2103120"/>
+            <a:ext cx="8229600" cy="3657600"/>
+          </a:xfrm>
+          <a:prstGeom prst="rect">
+            <a:avLst/>
+          </a:prstGeom>
+          <a:noFill/>
+        </p:spPr>
+        <p:txBody>
+          <a:bodyPr wrap="square">
+            <a:spAutoFit/>
+          </a:bodyPr>
+          <a:lstStyle/>
+          <a:p>
+            <a:r>
+              <a:rPr sz="1100">
+                <a:solidFill>
+                  <a:srgbClr val="A6E3A1"/>
+                </a:solidFill>
+                <a:latin typeface="Courier New"/>
+              </a:rPr>
+              <a:t># tools.py — session context</a:t>
+            </a:r>
+          </a:p>
+          <a:p>
+            <a:r>
+              <a:rPr sz="1100">
+                <a:solidFill>
+                  <a:srgbClr val="A6E3A1"/>
+                </a:solidFill>
+                <a:latin typeface="Courier New"/>
+              </a:rPr>
+              <a:t>_current_session_id: str = "unknown"</a:t>
+            </a:r>
+          </a:p>
+          <a:p>
+            <a:r>
+              <a:rPr sz="1100">
+                <a:solidFill>
+                  <a:srgbClr val="A6E3A1"/>
+                </a:solidFill>
+                <a:latin typeface="Courier New"/>
+              </a:rPr>
+              <a:t/>
+            </a:r>
+          </a:p>
+          <a:p>
+            <a:r>
+              <a:rPr sz="1100">
+                <a:solidFill>
+                  <a:srgbClr val="A6E3A1"/>
+                </a:solidFill>
+                <a:latin typeface="Courier New"/>
+              </a:rPr>
+              <a:t>def set_session_context(session_id: str) -&gt; None:</a:t>
+            </a:r>
+          </a:p>
+          <a:p>
+            <a:r>
+              <a:rPr sz="1100">
+                <a:solidFill>
+                  <a:srgbClr val="A6E3A1"/>
+                </a:solidFill>
+                <a:latin typeface="Courier New"/>
+              </a:rPr>
+              <a:t>    global _current_session_id</a:t>
+            </a:r>
+          </a:p>
+          <a:p>
+            <a:r>
+              <a:rPr sz="1100">
+                <a:solidFill>
+                  <a:srgbClr val="A6E3A1"/>
+                </a:solidFill>
+                <a:latin typeface="Courier New"/>
+              </a:rPr>
+              <a:t>    _current_session_id = session_id   # called by assistant.start_session()</a:t>
+            </a:r>
+          </a:p>
+          <a:p>
+            <a:r>
+              <a:rPr sz="1100">
+                <a:solidFill>
+                  <a:srgbClr val="A6E3A1"/>
+                </a:solidFill>
+                <a:latin typeface="Courier New"/>
+              </a:rPr>
+              <a:t/>
+            </a:r>
+          </a:p>
+          <a:p>
+            <a:r>
+              <a:rPr sz="1100">
+                <a:solidFill>
+                  <a:srgbClr val="A6E3A1"/>
+                </a:solidFill>
+                <a:latin typeface="Courier New"/>
+              </a:rPr>
+              <a:t>class ToolLogger:</a:t>
+            </a:r>
+          </a:p>
+          <a:p>
+            <a:r>
+              <a:rPr sz="1100">
+                <a:solidFill>
+                  <a:srgbClr val="A6E3A1"/>
+                </a:solidFill>
+                <a:latin typeface="Courier New"/>
+              </a:rPr>
+              <a:t>    @staticmethod</a:t>
+            </a:r>
+          </a:p>
+          <a:p>
+            <a:r>
+              <a:rPr sz="1100">
+                <a:solidFill>
+                  <a:srgbClr val="A6E3A1"/>
+                </a:solidFill>
+                <a:latin typeface="Courier New"/>
+              </a:rPr>
+              <a:t>    def log(tool_name, input_data, output, status="OK"):</a:t>
+            </a:r>
+          </a:p>
+          <a:p>
+            <a:r>
+              <a:rPr sz="1100">
+                <a:solidFill>
+                  <a:srgbClr val="A6E3A1"/>
+                </a:solidFill>
+                <a:latin typeface="Courier New"/>
+              </a:rPr>
+              <a:t>        log_file = Path("logs") / f"{_current_session_id}.log"</a:t>
+            </a:r>
+          </a:p>
+          <a:p>
+            <a:r>
+              <a:rPr sz="1100">
+                <a:solidFill>
+                  <a:srgbClr val="A6E3A1"/>
+                </a:solidFill>
+                <a:latin typeface="Courier New"/>
+              </a:rPr>
+              <a:t>        with open(log_file, "a") as f:</a:t>
+            </a:r>
+          </a:p>
+          <a:p>
+            <a:r>
+              <a:rPr sz="1100">
+                <a:solidFill>
+                  <a:srgbClr val="A6E3A1"/>
+                </a:solidFill>
+                <a:latin typeface="Courier New"/>
+              </a:rPr>
+              <a:t>            f.write(f"[{ts}]  Tool: {tool_name}  |  Status: {status}\n")</a:t>
+            </a:r>
+          </a:p>
+          <a:p>
+            <a:r>
+              <a:rPr sz="1100">
+                <a:solidFill>
+                  <a:srgbClr val="A6E3A1"/>
+                </a:solidFill>
+                <a:latin typeface="Courier New"/>
+              </a:rPr>
+              <a:t>            f.write(f"  Input:  {input_data}\n")</a:t>
+            </a:r>
+          </a:p>
+          <a:p>
+            <a:r>
+              <a:rPr sz="1100">
+                <a:solidFill>
+                  <a:srgbClr val="A6E3A1"/>
+                </a:solidFill>
+                <a:latin typeface="Courier New"/>
+              </a:rPr>
+              <a:t>            f.write(f"  Output: {output}\n\n")   # no truncation</a:t>
+            </a:r>
+          </a:p>
+          <a:p>
+            <a:r>
+              <a:rPr sz="1100">
+                <a:solidFill>
+                  <a:srgbClr val="A6E3A1"/>
+                </a:solidFill>
+                <a:latin typeface="Courier New"/>
+              </a:rPr>
+              <a:t/>
+            </a:r>
+          </a:p>
+          <a:p>
+            <a:r>
+              <a:rPr sz="1100">
+                <a:solidFill>
+                  <a:srgbClr val="A6E3A1"/>
+                </a:solidFill>
+                <a:latin typeface="Courier New"/>
+              </a:rPr>
+              <a:t># Status labels: LIST | EXACT_MATCH | KEYWORD_MATCH | FALLBACK_ALL</a:t>
+            </a:r>
+          </a:p>
+          <a:p>
+            <a:r>
+              <a:rPr sz="1100">
+                <a:solidFill>
+                  <a:srgbClr val="A6E3A1"/>
+                </a:solidFill>
+                <a:latin typeface="Courier New"/>
+              </a:rPr>
+              <a:t>#                NO_MATCH | ERROR | INVALID_INPUT | ZERO_DIVISION | FALLBACK</a:t>
+            </a:r>
+          </a:p>
+        </p:txBody>
+      </p:sp>
+    </p:spTree>
+  </p:cSld>
+  <p:clrMapOvr>
+    <a:masterClrMapping/>
+  </p:clrMapOvr>
+</p:sld>
+</file>
+
+<file path=ppt/slides/slide25.xml><?xml version="1.0" encoding="utf-8"?>
+<p:sld xmlns:a="http://schemas.openxmlformats.org/drawingml/2006/main" xmlns:p="http://schemas.openxmlformats.org/presentationml/2006/main" xmlns:r="http://schemas.openxmlformats.org/officeDocument/2006/relationships">
+  <p:cSld>
+    <p:bg>
+      <p:bgPr>
+        <a:solidFill>
+          <a:srgbClr val="1E1E2E"/>
+        </a:solidFill>
+        <a:effectLst/>
+      </p:bgPr>
+    </p:bg>
+    <p:spTree>
+      <p:nvGrpSpPr>
+        <p:cNvPr id="1" name=""/>
+        <p:cNvGrpSpPr/>
+        <p:nvPr/>
+      </p:nvGrpSpPr>
+      <p:grpSpPr/>
+      <p:sp>
+        <p:nvSpPr>
+          <p:cNvPr id="2" name="TextBox 1"/>
+          <p:cNvSpPr txBox="1"/>
+          <p:nvPr/>
+        </p:nvSpPr>
+        <p:spPr>
+          <a:xfrm>
+            <a:off x="365760" y="228600"/>
+            <a:ext cx="8412480" cy="594360"/>
+          </a:xfrm>
+          <a:prstGeom prst="rect">
+            <a:avLst/>
+          </a:prstGeom>
+          <a:noFill/>
+        </p:spPr>
+        <p:txBody>
+          <a:bodyPr wrap="none">
+            <a:spAutoFit/>
+          </a:bodyPr>
+          <a:lstStyle/>
+          <a:p>
+            <a:pPr algn="l"/>
+            <a:r>
+              <a:rPr b="1" sz="2400">
+                <a:solidFill>
+                  <a:srgbClr val="74C7EC"/>
+                </a:solidFill>
+              </a:rPr>
+              <a:t>Update 4 — Full Conversation History in sessions/</a:t>
+            </a:r>
+          </a:p>
+        </p:txBody>
+      </p:sp>
+      <p:sp>
+        <p:nvSpPr>
+          <p:cNvPr id="3" name="TextBox 2"/>
+          <p:cNvSpPr txBox="1"/>
+          <p:nvPr/>
+        </p:nvSpPr>
+        <p:spPr>
+          <a:xfrm>
+            <a:off x="365760" y="914400"/>
+            <a:ext cx="8412480" cy="685800"/>
+          </a:xfrm>
+          <a:prstGeom prst="rect">
+            <a:avLst/>
+          </a:prstGeom>
+          <a:noFill/>
+        </p:spPr>
+        <p:txBody>
+          <a:bodyPr wrap="square">
+            <a:spAutoFit/>
+          </a:bodyPr>
+          <a:lstStyle/>
+          <a:p>
+            <a:pPr algn="l"/>
+            <a:r>
+              <a:rPr sz="1300" b="0">
+                <a:solidFill>
+                  <a:srgbClr val="CDD6F4"/>
+                </a:solidFill>
+              </a:rPr>
+              <a:t>OLD: sessions/&lt;uuid&gt;.json had only metadata (session_id, user_id, message_count)</a:t>
+            </a:r>
+          </a:p>
+          <a:p>
+            <a:pPr algn="l"/>
+            <a:r>
+              <a:rPr sz="1300" b="0">
+                <a:solidFill>
+                  <a:srgbClr val="CDD6F4"/>
+                </a:solidFill>
+              </a:rPr>
+              <a:t>NEW: Each turn is appended to conversation_history with full detail</a:t>
+            </a:r>
+          </a:p>
+        </p:txBody>
+      </p:sp>
+      <p:sp>
+        <p:nvSpPr>
+          <p:cNvPr id="4" name="Rectangle 3"/>
+          <p:cNvSpPr/>
+          <p:nvPr/>
+        </p:nvSpPr>
+        <p:spPr>
+          <a:xfrm>
+            <a:off x="365760" y="1737360"/>
+            <a:ext cx="8412480" cy="4114800"/>
+          </a:xfrm>
+          <a:prstGeom prst="rect">
+            <a:avLst/>
+          </a:prstGeom>
+          <a:solidFill>
+            <a:srgbClr val="18182E"/>
+          </a:solidFill>
+          <a:ln>
+            <a:noFill/>
+          </a:ln>
+        </p:spPr>
+        <p:style>
+          <a:lnRef idx="1">
+            <a:schemeClr val="accent1"/>
+          </a:lnRef>
+          <a:fillRef idx="3">
+            <a:schemeClr val="accent1"/>
+          </a:fillRef>
+          <a:effectRef idx="2">
+            <a:schemeClr val="accent1"/>
+          </a:effectRef>
+          <a:fontRef idx="minor">
+            <a:schemeClr val="lt1"/>
+          </a:fontRef>
+        </p:style>
+        <p:txBody>
+          <a:bodyPr rtlCol="0" anchor="ctr"/>
+          <a:lstStyle/>
+          <a:p>
+            <a:pPr algn="ctr"/>
+          </a:p>
+        </p:txBody>
+      </p:sp>
+      <p:sp>
+        <p:nvSpPr>
+          <p:cNvPr id="5" name="TextBox 4"/>
+          <p:cNvSpPr txBox="1"/>
+          <p:nvPr/>
+        </p:nvSpPr>
+        <p:spPr>
+          <a:xfrm>
+            <a:off x="457200" y="1828800"/>
+            <a:ext cx="8229600" cy="3931920"/>
+          </a:xfrm>
+          <a:prstGeom prst="rect">
+            <a:avLst/>
+          </a:prstGeom>
+          <a:noFill/>
+        </p:spPr>
+        <p:txBody>
+          <a:bodyPr wrap="square">
+            <a:spAutoFit/>
+          </a:bodyPr>
+          <a:lstStyle/>
+          <a:p>
+            <a:r>
+              <a:rPr sz="1100">
+                <a:solidFill>
+                  <a:srgbClr val="A6E3A1"/>
+                </a:solidFill>
+                <a:latin typeface="Courier New"/>
+              </a:rPr>
+              <a:t>{</a:t>
+            </a:r>
+          </a:p>
+          <a:p>
+            <a:r>
+              <a:rPr sz="1100">
+                <a:solidFill>
+                  <a:srgbClr val="A6E3A1"/>
+                </a:solidFill>
+                <a:latin typeface="Courier New"/>
+              </a:rPr>
+              <a:t>  "session_id": "c3d4e5f6-calculation-revenue-session",</a:t>
+            </a:r>
+          </a:p>
+          <a:p>
+            <a:r>
+              <a:rPr sz="1100">
+                <a:solidFill>
+                  <a:srgbClr val="A6E3A1"/>
+                </a:solidFill>
+                <a:latin typeface="Courier New"/>
+              </a:rPr>
+              <a:t>  "user_id": "user_001",</a:t>
+            </a:r>
+          </a:p>
+          <a:p>
+            <a:r>
+              <a:rPr sz="1100">
+                <a:solidFill>
+                  <a:srgbClr val="A6E3A1"/>
+                </a:solidFill>
+                <a:latin typeface="Courier New"/>
+              </a:rPr>
+              <a:t>  "created_at": "2026-10-05T11:20:00",</a:t>
+            </a:r>
+          </a:p>
+          <a:p>
+            <a:r>
+              <a:rPr sz="1100">
+                <a:solidFill>
+                  <a:srgbClr val="A6E3A1"/>
+                </a:solidFill>
+                <a:latin typeface="Courier New"/>
+              </a:rPr>
+              <a:t>  "message_count": 3,</a:t>
+            </a:r>
+          </a:p>
+          <a:p>
+            <a:r>
+              <a:rPr sz="1100">
+                <a:solidFill>
+                  <a:srgbClr val="A6E3A1"/>
+                </a:solidFill>
+                <a:latin typeface="Courier New"/>
+              </a:rPr>
+              <a:t>  "conversation_history": [</a:t>
+            </a:r>
+          </a:p>
+          <a:p>
+            <a:r>
+              <a:rPr sz="1100">
+                <a:solidFill>
+                  <a:srgbClr val="A6E3A1"/>
+                </a:solidFill>
+                <a:latin typeface="Courier New"/>
+              </a:rPr>
+              <a:t>    {</a:t>
+            </a:r>
+          </a:p>
+          <a:p>
+            <a:r>
+              <a:rPr sz="1100">
+                <a:solidFill>
+                  <a:srgbClr val="A6E3A1"/>
+                </a:solidFill>
+                <a:latin typeface="Courier New"/>
+              </a:rPr>
+              <a:t>      "turn": 1,</a:t>
+            </a:r>
+          </a:p>
+          <a:p>
+            <a:r>
+              <a:rPr sz="1100">
+                <a:solidFill>
+                  <a:srgbClr val="A6E3A1"/>
+                </a:solidFill>
+                <a:latin typeface="Courier New"/>
+              </a:rPr>
+              <a:t>      "timestamp": "2026-10-05T11:20:15",</a:t>
+            </a:r>
+          </a:p>
+          <a:p>
+            <a:r>
+              <a:rPr sz="1100">
+                <a:solidFill>
+                  <a:srgbClr val="A6E3A1"/>
+                </a:solidFill>
+                <a:latin typeface="Courier New"/>
+              </a:rPr>
+              <a:t>      "user_input": "Calculate: total revenue Q1 and Q2",</a:t>
+            </a:r>
+          </a:p>
+          <a:p>
+            <a:r>
+              <a:rPr sz="1100">
+                <a:solidFill>
+                  <a:srgbClr val="A6E3A1"/>
+                </a:solidFill>
+                <a:latin typeface="Courier New"/>
+              </a:rPr>
+              <a:t>      "intent_type": "calculation",</a:t>
+            </a:r>
+          </a:p>
+          <a:p>
+            <a:r>
+              <a:rPr sz="1100">
+                <a:solidFill>
+                  <a:srgbClr val="A6E3A1"/>
+                </a:solidFill>
+                <a:latin typeface="Courier New"/>
+              </a:rPr>
+              <a:t>      "intent_confidence": 0.97,</a:t>
+            </a:r>
+          </a:p>
+          <a:p>
+            <a:r>
+              <a:rPr sz="1100">
+                <a:solidFill>
+                  <a:srgbClr val="A6E3A1"/>
+                </a:solidFill>
+                <a:latin typeface="Courier New"/>
+              </a:rPr>
+              <a:t>      "intent_reasoning": "Prefix 'Calculate:' is explicit; adding two revenue figures requires arithmetic.",</a:t>
+            </a:r>
+          </a:p>
+          <a:p>
+            <a:r>
+              <a:rPr sz="1100">
+                <a:solidFill>
+                  <a:srgbClr val="A6E3A1"/>
+                </a:solidFill>
+                <a:latin typeface="Courier New"/>
+              </a:rPr>
+              <a:t>      "tools_used": ["document_reader", "calculator"],</a:t>
+            </a:r>
+          </a:p>
+          <a:p>
+            <a:r>
+              <a:rPr sz="1100">
+                <a:solidFill>
+                  <a:srgbClr val="A6E3A1"/>
+                </a:solidFill>
+                <a:latin typeface="Courier New"/>
+              </a:rPr>
+              <a:t>      "sources": ["doc_financial_q1", "doc_financial_q2"],</a:t>
+            </a:r>
+          </a:p>
+          <a:p>
+            <a:r>
+              <a:rPr sz="1100">
+                <a:solidFill>
+                  <a:srgbClr val="A6E3A1"/>
+                </a:solidFill>
+                <a:latin typeface="Courier New"/>
+              </a:rPr>
+              <a:t>      "response": "Combined revenue is $9,300,000 ...",</a:t>
+            </a:r>
+          </a:p>
+          <a:p>
+            <a:r>
+              <a:rPr sz="1100">
+                <a:solidFill>
+                  <a:srgbClr val="A6E3A1"/>
+                </a:solidFill>
+                <a:latin typeface="Courier New"/>
+              </a:rPr>
+              <a:t>      "conversation_summary": "..."</a:t>
+            </a:r>
+          </a:p>
+          <a:p>
+            <a:r>
+              <a:rPr sz="1100">
+                <a:solidFill>
+                  <a:srgbClr val="A6E3A1"/>
+                </a:solidFill>
+                <a:latin typeface="Courier New"/>
+              </a:rPr>
+              <a:t>    }</a:t>
+            </a:r>
+          </a:p>
+          <a:p>
+            <a:r>
+              <a:rPr sz="1100">
+                <a:solidFill>
+                  <a:srgbClr val="A6E3A1"/>
+                </a:solidFill>
+                <a:latin typeface="Courier New"/>
+              </a:rPr>
+              <a:t>  ]</a:t>
+            </a:r>
+          </a:p>
+          <a:p>
+            <a:r>
+              <a:rPr sz="1100">
+                <a:solidFill>
+                  <a:srgbClr val="A6E3A1"/>
+                </a:solidFill>
+                <a:latin typeface="Courier New"/>
+              </a:rPr>
+              <a:t>}</a:t>
+            </a:r>
+          </a:p>
+        </p:txBody>
+      </p:sp>
+    </p:spTree>
+  </p:cSld>
+  <p:clrMapOvr>
+    <a:masterClrMapping/>
+  </p:clrMapOvr>
+</p:sld>
+</file>
+
+<file path=ppt/slides/slide26.xml><?xml version="1.0" encoding="utf-8"?>
+<p:sld xmlns:a="http://schemas.openxmlformats.org/drawingml/2006/main" xmlns:p="http://schemas.openxmlformats.org/presentationml/2006/main" xmlns:r="http://schemas.openxmlformats.org/officeDocument/2006/relationships">
+  <p:cSld>
+    <p:bg>
+      <p:bgPr>
+        <a:solidFill>
+          <a:srgbClr val="1E1E2E"/>
+        </a:solidFill>
+        <a:effectLst/>
+      </p:bgPr>
+    </p:bg>
+    <p:spTree>
+      <p:nvGrpSpPr>
+        <p:cNvPr id="1" name=""/>
+        <p:cNvGrpSpPr/>
+        <p:nvPr/>
+      </p:nvGrpSpPr>
+      <p:grpSpPr/>
+      <p:sp>
+        <p:nvSpPr>
+          <p:cNvPr id="2" name="TextBox 1"/>
+          <p:cNvSpPr txBox="1"/>
+          <p:nvPr/>
+        </p:nvSpPr>
+        <p:spPr>
+          <a:xfrm>
+            <a:off x="365760" y="228600"/>
+            <a:ext cx="8412480" cy="594360"/>
+          </a:xfrm>
+          <a:prstGeom prst="rect">
+            <a:avLst/>
+          </a:prstGeom>
+          <a:noFill/>
+        </p:spPr>
+        <p:txBody>
+          <a:bodyPr wrap="none">
+            <a:spAutoFit/>
+          </a:bodyPr>
+          <a:lstStyle/>
+          <a:p>
+            <a:pPr algn="l"/>
+            <a:r>
+              <a:rPr b="1" sz="2400">
+                <a:solidFill>
+                  <a:srgbClr val="74C7EC"/>
+                </a:solidFill>
+              </a:rPr>
+              <a:t>Update 5 — MessagesPlaceholder in ChatPromptTemplate</a:t>
+            </a:r>
+          </a:p>
+        </p:txBody>
+      </p:sp>
+      <p:sp>
+        <p:nvSpPr>
+          <p:cNvPr id="3" name="TextBox 2"/>
+          <p:cNvSpPr txBox="1"/>
+          <p:nvPr/>
+        </p:nvSpPr>
+        <p:spPr>
+          <a:xfrm>
+            <a:off x="365760" y="914400"/>
+            <a:ext cx="8412480" cy="685800"/>
+          </a:xfrm>
+          <a:prstGeom prst="rect">
+            <a:avLst/>
+          </a:prstGeom>
+          <a:noFill/>
+        </p:spPr>
+        <p:txBody>
+          <a:bodyPr wrap="square">
+            <a:spAutoFit/>
+          </a:bodyPr>
+          <a:lstStyle/>
+          <a:p>
+            <a:pPr algn="l"/>
+            <a:r>
+              <a:rPr sz="1300" b="0">
+                <a:solidFill>
+                  <a:srgbClr val="CDD6F4"/>
+                </a:solidFill>
+              </a:rPr>
+              <a:t>All three agent prompt templates now include MessagesPlaceholder</a:t>
+            </a:r>
+          </a:p>
+          <a:p>
+            <a:pPr algn="l"/>
+            <a:r>
+              <a:rPr sz="1300" b="0">
+                <a:solidFill>
+                  <a:srgbClr val="CDD6F4"/>
+                </a:solidFill>
+              </a:rPr>
+              <a:t>so prior conversation turns are visible to the LLM (multi-turn context).</a:t>
+            </a:r>
+          </a:p>
+        </p:txBody>
+      </p:sp>
+      <p:sp>
+        <p:nvSpPr>
+          <p:cNvPr id="4" name="Rectangle 3"/>
+          <p:cNvSpPr/>
+          <p:nvPr/>
+        </p:nvSpPr>
+        <p:spPr>
+          <a:xfrm>
+            <a:off x="365760" y="1737360"/>
+            <a:ext cx="8412480" cy="4114800"/>
+          </a:xfrm>
+          <a:prstGeom prst="rect">
+            <a:avLst/>
+          </a:prstGeom>
+          <a:solidFill>
+            <a:srgbClr val="18182E"/>
+          </a:solidFill>
+          <a:ln>
+            <a:noFill/>
+          </a:ln>
+        </p:spPr>
+        <p:style>
+          <a:lnRef idx="1">
+            <a:schemeClr val="accent1"/>
+          </a:lnRef>
+          <a:fillRef idx="3">
+            <a:schemeClr val="accent1"/>
+          </a:fillRef>
+          <a:effectRef idx="2">
+            <a:schemeClr val="accent1"/>
+          </a:effectRef>
+          <a:fontRef idx="minor">
+            <a:schemeClr val="lt1"/>
+          </a:fontRef>
+        </p:style>
+        <p:txBody>
+          <a:bodyPr rtlCol="0" anchor="ctr"/>
+          <a:lstStyle/>
+          <a:p>
+            <a:pPr algn="ctr"/>
+          </a:p>
+        </p:txBody>
+      </p:sp>
+      <p:sp>
+        <p:nvSpPr>
+          <p:cNvPr id="5" name="TextBox 4"/>
+          <p:cNvSpPr txBox="1"/>
+          <p:nvPr/>
+        </p:nvSpPr>
+        <p:spPr>
+          <a:xfrm>
+            <a:off x="457200" y="1828800"/>
+            <a:ext cx="8229600" cy="3931920"/>
+          </a:xfrm>
+          <a:prstGeom prst="rect">
+            <a:avLst/>
+          </a:prstGeom>
+          <a:noFill/>
+        </p:spPr>
+        <p:txBody>
+          <a:bodyPr wrap="square">
+            <a:spAutoFit/>
+          </a:bodyPr>
+          <a:lstStyle/>
+          <a:p>
+            <a:r>
+              <a:rPr sz="1100">
+                <a:solidFill>
+                  <a:srgbClr val="A6E3A1"/>
+                </a:solidFill>
+                <a:latin typeface="Courier New"/>
+              </a:rPr>
+              <a:t># prompts.py — BEFORE</a:t>
+            </a:r>
+          </a:p>
+          <a:p>
+            <a:r>
+              <a:rPr sz="1100">
+                <a:solidFill>
+                  <a:srgbClr val="A6E3A1"/>
+                </a:solidFill>
+                <a:latin typeface="Courier New"/>
+              </a:rPr>
+              <a:t>from langchain_core.prompts import PromptTemplate, ChatPromptTemplate</a:t>
+            </a:r>
+          </a:p>
+          <a:p>
+            <a:r>
+              <a:rPr sz="1100">
+                <a:solidFill>
+                  <a:srgbClr val="A6E3A1"/>
+                </a:solidFill>
+                <a:latin typeface="Courier New"/>
+              </a:rPr>
+              <a:t/>
+            </a:r>
+          </a:p>
+          <a:p>
+            <a:r>
+              <a:rPr sz="1100">
+                <a:solidFill>
+                  <a:srgbClr val="A6E3A1"/>
+                </a:solidFill>
+                <a:latin typeface="Courier New"/>
+              </a:rPr>
+              <a:t>return ChatPromptTemplate.from_messages([</a:t>
+            </a:r>
+          </a:p>
+          <a:p>
+            <a:r>
+              <a:rPr sz="1100">
+                <a:solidFill>
+                  <a:srgbClr val="A6E3A1"/>
+                </a:solidFill>
+                <a:latin typeface="Courier New"/>
+              </a:rPr>
+              <a:t>    ("system", system_prompt),</a:t>
+            </a:r>
+          </a:p>
+          <a:p>
+            <a:r>
+              <a:rPr sz="1100">
+                <a:solidFill>
+                  <a:srgbClr val="A6E3A1"/>
+                </a:solidFill>
+                <a:latin typeface="Courier New"/>
+              </a:rPr>
+              <a:t>    ("human", "{user_input}"),</a:t>
+            </a:r>
+          </a:p>
+          <a:p>
+            <a:r>
+              <a:rPr sz="1100">
+                <a:solidFill>
+                  <a:srgbClr val="A6E3A1"/>
+                </a:solidFill>
+                <a:latin typeface="Courier New"/>
+              </a:rPr>
+              <a:t>])</a:t>
+            </a:r>
+          </a:p>
+          <a:p>
+            <a:r>
+              <a:rPr sz="1100">
+                <a:solidFill>
+                  <a:srgbClr val="A6E3A1"/>
+                </a:solidFill>
+                <a:latin typeface="Courier New"/>
+              </a:rPr>
+              <a:t/>
+            </a:r>
+          </a:p>
+          <a:p>
+            <a:r>
+              <a:rPr sz="1100">
+                <a:solidFill>
+                  <a:srgbClr val="A6E3A1"/>
+                </a:solidFill>
+                <a:latin typeface="Courier New"/>
+              </a:rPr>
+              <a:t/>
+            </a:r>
+          </a:p>
+          <a:p>
+            <a:r>
+              <a:rPr sz="1100">
+                <a:solidFill>
+                  <a:srgbClr val="A6E3A1"/>
+                </a:solidFill>
+                <a:latin typeface="Courier New"/>
+              </a:rPr>
+              <a:t># prompts.py — AFTER</a:t>
+            </a:r>
+          </a:p>
+          <a:p>
+            <a:r>
+              <a:rPr sz="1100">
+                <a:solidFill>
+                  <a:srgbClr val="A6E3A1"/>
+                </a:solidFill>
+                <a:latin typeface="Courier New"/>
+              </a:rPr>
+              <a:t>from langchain_core.prompts import (</a:t>
+            </a:r>
+          </a:p>
+          <a:p>
+            <a:r>
+              <a:rPr sz="1100">
+                <a:solidFill>
+                  <a:srgbClr val="A6E3A1"/>
+                </a:solidFill>
+                <a:latin typeface="Courier New"/>
+              </a:rPr>
+              <a:t>    PromptTemplate, ChatPromptTemplate, MessagesPlaceholder</a:t>
+            </a:r>
+          </a:p>
+          <a:p>
+            <a:r>
+              <a:rPr sz="1100">
+                <a:solidFill>
+                  <a:srgbClr val="A6E3A1"/>
+                </a:solidFill>
+                <a:latin typeface="Courier New"/>
+              </a:rPr>
+              <a:t>)</a:t>
+            </a:r>
+          </a:p>
+          <a:p>
+            <a:r>
+              <a:rPr sz="1100">
+                <a:solidFill>
+                  <a:srgbClr val="A6E3A1"/>
+                </a:solidFill>
+                <a:latin typeface="Courier New"/>
+              </a:rPr>
+              <a:t/>
+            </a:r>
+          </a:p>
+          <a:p>
+            <a:r>
+              <a:rPr sz="1100">
+                <a:solidFill>
+                  <a:srgbClr val="A6E3A1"/>
+                </a:solidFill>
+                <a:latin typeface="Courier New"/>
+              </a:rPr>
+              <a:t>return ChatPromptTemplate.from_messages([</a:t>
+            </a:r>
+          </a:p>
+          <a:p>
+            <a:r>
+              <a:rPr sz="1100">
+                <a:solidFill>
+                  <a:srgbClr val="A6E3A1"/>
+                </a:solidFill>
+                <a:latin typeface="Courier New"/>
+              </a:rPr>
+              <a:t>    ("system", system_prompt),</a:t>
+            </a:r>
+          </a:p>
+          <a:p>
+            <a:r>
+              <a:rPr sz="1100">
+                <a:solidFill>
+                  <a:srgbClr val="A6E3A1"/>
+                </a:solidFill>
+                <a:latin typeface="Courier New"/>
+              </a:rPr>
+              <a:t>    MessagesPlaceholder(variable_name="conversation_history", optional=True),</a:t>
+            </a:r>
+          </a:p>
+          <a:p>
+            <a:r>
+              <a:rPr sz="1100">
+                <a:solidFill>
+                  <a:srgbClr val="A6E3A1"/>
+                </a:solidFill>
+                <a:latin typeface="Courier New"/>
+              </a:rPr>
+              <a:t>    ("human", "{user_input}"),</a:t>
+            </a:r>
+          </a:p>
+          <a:p>
+            <a:r>
+              <a:rPr sz="1100">
+                <a:solidFill>
+                  <a:srgbClr val="A6E3A1"/>
+                </a:solidFill>
+                <a:latin typeface="Courier New"/>
+              </a:rPr>
+              <a:t>])</a:t>
+            </a:r>
+          </a:p>
+          <a:p>
+            <a:r>
+              <a:rPr sz="1100">
+                <a:solidFill>
+                  <a:srgbClr val="A6E3A1"/>
+                </a:solidFill>
+                <a:latin typeface="Courier New"/>
+              </a:rPr>
+              <a:t/>
+            </a:r>
+          </a:p>
+          <a:p>
+            <a:r>
+              <a:rPr sz="1100">
+                <a:solidFill>
+                  <a:srgbClr val="A6E3A1"/>
+                </a:solidFill>
+                <a:latin typeface="Courier New"/>
+              </a:rPr>
+              <a:t/>
+            </a:r>
+          </a:p>
+          <a:p>
+            <a:r>
+              <a:rPr sz="1100">
+                <a:solidFill>
+                  <a:srgbClr val="A6E3A1"/>
+                </a:solidFill>
+                <a:latin typeface="Courier New"/>
+              </a:rPr>
+              <a:t># agent.py — each agent now passes history into format_messages()</a:t>
+            </a:r>
+          </a:p>
+          <a:p>
+            <a:r>
+              <a:rPr sz="1100">
+                <a:solidFill>
+                  <a:srgbClr val="A6E3A1"/>
+                </a:solidFill>
+                <a:latin typeface="Courier New"/>
+              </a:rPr>
+              <a:t>recent_history = state.get("messages", [])[-6:]</a:t>
+            </a:r>
+          </a:p>
+          <a:p>
+            <a:r>
+              <a:rPr sz="1100">
+                <a:solidFill>
+                  <a:srgbClr val="A6E3A1"/>
+                </a:solidFill>
+                <a:latin typeface="Courier New"/>
+              </a:rPr>
+              <a:t>messages = prompt_template.format_messages(</a:t>
+            </a:r>
+          </a:p>
+          <a:p>
+            <a:r>
+              <a:rPr sz="1100">
+                <a:solidFill>
+                  <a:srgbClr val="A6E3A1"/>
+                </a:solidFill>
+                <a:latin typeface="Courier New"/>
+              </a:rPr>
+              <a:t>    user_input=enriched_input,</a:t>
+            </a:r>
+          </a:p>
+          <a:p>
+            <a:r>
+              <a:rPr sz="1100">
+                <a:solidFill>
+                  <a:srgbClr val="A6E3A1"/>
+                </a:solidFill>
+                <a:latin typeface="Courier New"/>
+              </a:rPr>
+              <a:t>    conversation_history=recent_history,</a:t>
+            </a:r>
+          </a:p>
+          <a:p>
+            <a:r>
+              <a:rPr sz="1100">
+                <a:solidFill>
+                  <a:srgbClr val="A6E3A1"/>
+                </a:solidFill>
+                <a:latin typeface="Courier New"/>
+              </a:rPr>
+              <a:t>)</a:t>
+            </a:r>
+          </a:p>
+        </p:txBody>
+      </p:sp>
+    </p:spTree>
+  </p:cSld>
+  <p:clrMapOvr>
+    <a:masterClrMapping/>
+  </p:clrMapOvr>
+</p:sld>
+</file>
+
+<file path=ppt/slides/slide27.xml><?xml version="1.0" encoding="utf-8"?>
+<p:sld xmlns:a="http://schemas.openxmlformats.org/drawingml/2006/main" xmlns:p="http://schemas.openxmlformats.org/presentationml/2006/main" xmlns:r="http://schemas.openxmlformats.org/officeDocument/2006/relationships">
+  <p:cSld>
+    <p:bg>
+      <p:bgPr>
+        <a:solidFill>
+          <a:srgbClr val="1E1E2E"/>
+        </a:solidFill>
+        <a:effectLst/>
+      </p:bgPr>
+    </p:bg>
+    <p:spTree>
+      <p:nvGrpSpPr>
+        <p:cNvPr id="1" name=""/>
+        <p:cNvGrpSpPr/>
+        <p:nvPr/>
+      </p:nvGrpSpPr>
+      <p:grpSpPr/>
+      <p:sp>
+        <p:nvSpPr>
+          <p:cNvPr id="2" name="TextBox 1"/>
+          <p:cNvSpPr txBox="1"/>
+          <p:nvPr/>
+        </p:nvSpPr>
+        <p:spPr>
+          <a:xfrm>
+            <a:off x="365760" y="228600"/>
+            <a:ext cx="8412480" cy="594360"/>
+          </a:xfrm>
+          <a:prstGeom prst="rect">
+            <a:avLst/>
+          </a:prstGeom>
+          <a:noFill/>
+        </p:spPr>
+        <p:txBody>
+          <a:bodyPr wrap="none">
+            <a:spAutoFit/>
+          </a:bodyPr>
+          <a:lstStyle/>
+          <a:p>
+            <a:pPr algn="l"/>
+            <a:r>
+              <a:rPr b="1" sz="2400">
+                <a:solidFill>
+                  <a:srgbClr val="74C7EC"/>
+                </a:solidFill>
+              </a:rPr>
+              <a:t>Update 6 — Enriched Intent Classification Prompt</a:t>
+            </a:r>
+          </a:p>
+        </p:txBody>
+      </p:sp>
+      <p:sp>
+        <p:nvSpPr>
+          <p:cNvPr id="3" name="TextBox 2"/>
+          <p:cNvSpPr txBox="1"/>
+          <p:nvPr/>
+        </p:nvSpPr>
+        <p:spPr>
+          <a:xfrm>
+            <a:off x="365760" y="914400"/>
+            <a:ext cx="8412480" cy="457200"/>
+          </a:xfrm>
+          <a:prstGeom prst="rect">
+            <a:avLst/>
+          </a:prstGeom>
+          <a:noFill/>
+        </p:spPr>
+        <p:txBody>
+          <a:bodyPr wrap="square">
+            <a:spAutoFit/>
+          </a:bodyPr>
+          <a:lstStyle/>
+          <a:p>
+            <a:pPr algn="l"/>
+            <a:r>
+              <a:rPr sz="1300" b="0">
+                <a:solidFill>
+                  <a:srgbClr val="CDD6F4"/>
+                </a:solidFill>
+              </a:rPr>
+              <a:t>Four improvements added to _INTENT_CLASSIFICATION_TEMPLATE in prompts.py:</a:t>
+            </a:r>
+          </a:p>
+        </p:txBody>
+      </p:sp>
+      <p:sp>
+        <p:nvSpPr>
+          <p:cNvPr id="4" name="Rectangle 3"/>
+          <p:cNvSpPr/>
+          <p:nvPr/>
+        </p:nvSpPr>
+        <p:spPr>
+          <a:xfrm>
+            <a:off x="365760" y="1463040"/>
+            <a:ext cx="8412480" cy="4389120"/>
+          </a:xfrm>
+          <a:prstGeom prst="rect">
+            <a:avLst/>
+          </a:prstGeom>
+          <a:solidFill>
+            <a:srgbClr val="18182E"/>
+          </a:solidFill>
+          <a:ln>
+            <a:noFill/>
+          </a:ln>
+        </p:spPr>
+        <p:style>
+          <a:lnRef idx="1">
+            <a:schemeClr val="accent1"/>
+          </a:lnRef>
+          <a:fillRef idx="3">
+            <a:schemeClr val="accent1"/>
+          </a:fillRef>
+          <a:effectRef idx="2">
+            <a:schemeClr val="accent1"/>
+          </a:effectRef>
+          <a:fontRef idx="minor">
+            <a:schemeClr val="lt1"/>
+          </a:fontRef>
+        </p:style>
+        <p:txBody>
+          <a:bodyPr rtlCol="0" anchor="ctr"/>
+          <a:lstStyle/>
+          <a:p>
+            <a:pPr algn="ctr"/>
+          </a:p>
+        </p:txBody>
+      </p:sp>
+      <p:sp>
+        <p:nvSpPr>
+          <p:cNvPr id="5" name="TextBox 4"/>
+          <p:cNvSpPr txBox="1"/>
+          <p:nvPr/>
+        </p:nvSpPr>
+        <p:spPr>
+          <a:xfrm>
+            <a:off x="457200" y="1554480"/>
+            <a:ext cx="8229600" cy="4206240"/>
+          </a:xfrm>
+          <a:prstGeom prst="rect">
+            <a:avLst/>
+          </a:prstGeom>
+          <a:noFill/>
+        </p:spPr>
+        <p:txBody>
+          <a:bodyPr wrap="square">
+            <a:spAutoFit/>
+          </a:bodyPr>
+          <a:lstStyle/>
+          <a:p>
+            <a:r>
+              <a:rPr sz="1100">
+                <a:solidFill>
+                  <a:srgbClr val="A6E3A1"/>
+                </a:solidFill>
+                <a:latin typeface="Courier New"/>
+              </a:rPr>
+              <a:t>1. EXAMPLES PER CATEGORY (3 per category)</a:t>
+            </a:r>
+          </a:p>
+          <a:p>
+            <a:r>
+              <a:rPr sz="1100">
+                <a:solidFill>
+                  <a:srgbClr val="A6E3A1"/>
+                </a:solidFill>
+                <a:latin typeface="Courier New"/>
+              </a:rPr>
+              <a:t>   "What is the readmission rate?" → qa,  confidence: 0.95</a:t>
+            </a:r>
+          </a:p>
+          <a:p>
+            <a:r>
+              <a:rPr sz="1100">
+                <a:solidFill>
+                  <a:srgbClr val="A6E3A1"/>
+                </a:solidFill>
+                <a:latin typeface="Courier New"/>
+              </a:rPr>
+              <a:t>     reasoning: "Direct factual question; no arithmetic required."</a:t>
+            </a:r>
+          </a:p>
+          <a:p>
+            <a:r>
+              <a:rPr sz="1100">
+                <a:solidFill>
+                  <a:srgbClr val="A6E3A1"/>
+                </a:solidFill>
+                <a:latin typeface="Courier New"/>
+              </a:rPr>
+              <a:t>   "Summarize the Q2 financial report" → summarization,  confidence: 0.97</a:t>
+            </a:r>
+          </a:p>
+          <a:p>
+            <a:r>
+              <a:rPr sz="1100">
+                <a:solidFill>
+                  <a:srgbClr val="A6E3A1"/>
+                </a:solidFill>
+                <a:latin typeface="Courier New"/>
+              </a:rPr>
+              <a:t>     reasoning: "'Summarize' is explicit; user wants condensed content."</a:t>
+            </a:r>
+          </a:p>
+          <a:p>
+            <a:r>
+              <a:rPr sz="1100">
+                <a:solidFill>
+                  <a:srgbClr val="A6E3A1"/>
+                </a:solidFill>
+                <a:latin typeface="Courier New"/>
+              </a:rPr>
+              <a:t>   "What is the combined revenue Q1+Q2?" → calculation,  confidence: 0.95</a:t>
+            </a:r>
+          </a:p>
+          <a:p>
+            <a:r>
+              <a:rPr sz="1100">
+                <a:solidFill>
+                  <a:srgbClr val="A6E3A1"/>
+                </a:solidFill>
+                <a:latin typeface="Courier New"/>
+              </a:rPr>
+              <a:t>     reasoning: "Requires adding two figures from separate documents."</a:t>
+            </a:r>
+          </a:p>
+          <a:p>
+            <a:r>
+              <a:rPr sz="1100">
+                <a:solidFill>
+                  <a:srgbClr val="A6E3A1"/>
+                </a:solidFill>
+                <a:latin typeface="Courier New"/>
+              </a:rPr>
+              <a:t/>
+            </a:r>
+          </a:p>
+          <a:p>
+            <a:r>
+              <a:rPr sz="1100">
+                <a:solidFill>
+                  <a:srgbClr val="A6E3A1"/>
+                </a:solidFill>
+                <a:latin typeface="Courier New"/>
+              </a:rPr>
+              <a:t>2. CONFIDENCE SCORING GUIDE</a:t>
+            </a:r>
+          </a:p>
+          <a:p>
+            <a:r>
+              <a:rPr sz="1100">
+                <a:solidFill>
+                  <a:srgbClr val="A6E3A1"/>
+                </a:solidFill>
+                <a:latin typeface="Courier New"/>
+              </a:rPr>
+              <a:t>   0.90–1.00  Intent is explicit and unambiguous</a:t>
+            </a:r>
+          </a:p>
+          <a:p>
+            <a:r>
+              <a:rPr sz="1100">
+                <a:solidFill>
+                  <a:srgbClr val="A6E3A1"/>
+                </a:solidFill>
+                <a:latin typeface="Courier New"/>
+              </a:rPr>
+              <a:t>   0.70–0.89  Likely correct but one other category is plausible</a:t>
+            </a:r>
+          </a:p>
+          <a:p>
+            <a:r>
+              <a:rPr sz="1100">
+                <a:solidFill>
+                  <a:srgbClr val="A6E3A1"/>
+                </a:solidFill>
+                <a:latin typeface="Courier New"/>
+              </a:rPr>
+              <a:t>   0.50–0.69  Genuinely ambiguous; fits two categories equally</a:t>
+            </a:r>
+          </a:p>
+          <a:p>
+            <a:r>
+              <a:rPr sz="1100">
+                <a:solidFill>
+                  <a:srgbClr val="A6E3A1"/>
+                </a:solidFill>
+                <a:latin typeface="Courier New"/>
+              </a:rPr>
+              <a:t>   Below 0.50  Very unclear — default to "qa"</a:t>
+            </a:r>
+          </a:p>
+          <a:p>
+            <a:r>
+              <a:rPr sz="1100">
+                <a:solidFill>
+                  <a:srgbClr val="A6E3A1"/>
+                </a:solidFill>
+                <a:latin typeface="Courier New"/>
+              </a:rPr>
+              <a:t/>
+            </a:r>
+          </a:p>
+          <a:p>
+            <a:r>
+              <a:rPr sz="1100">
+                <a:solidFill>
+                  <a:srgbClr val="A6E3A1"/>
+                </a:solidFill>
+                <a:latin typeface="Courier New"/>
+              </a:rPr>
+              <a:t>3. TIE-BREAKING RULES</a:t>
+            </a:r>
+          </a:p>
+          <a:p>
+            <a:r>
+              <a:rPr sz="1100">
+                <a:solidFill>
+                  <a:srgbClr val="A6E3A1"/>
+                </a:solidFill>
+                <a:latin typeface="Courier New"/>
+              </a:rPr>
+              <a:t>   • Any request needing arithmetic → "calculation" (beats "qa")</a:t>
+            </a:r>
+          </a:p>
+          <a:p>
+            <a:r>
+              <a:rPr sz="1100">
+                <a:solidFill>
+                  <a:srgbClr val="A6E3A1"/>
+                </a:solidFill>
+                <a:latin typeface="Courier New"/>
+              </a:rPr>
+              <a:t>   • "overview / highlight / tell me about" → "summarization"</a:t>
+            </a:r>
+          </a:p>
+          <a:p>
+            <a:r>
+              <a:rPr sz="1100">
+                <a:solidFill>
+                  <a:srgbClr val="A6E3A1"/>
+                </a:solidFill>
+                <a:latin typeface="Courier New"/>
+              </a:rPr>
+              <a:t>   • Follow-up requests → inherit intent from conversation_history</a:t>
+            </a:r>
+          </a:p>
+          <a:p>
+            <a:r>
+              <a:rPr sz="1100">
+                <a:solidFill>
+                  <a:srgbClr val="A6E3A1"/>
+                </a:solidFill>
+                <a:latin typeface="Courier New"/>
+              </a:rPr>
+              <a:t>   • Uncertain → "qa" is the safe fallback</a:t>
+            </a:r>
+          </a:p>
+          <a:p>
+            <a:r>
+              <a:rPr sz="1100">
+                <a:solidFill>
+                  <a:srgbClr val="A6E3A1"/>
+                </a:solidFill>
+                <a:latin typeface="Courier New"/>
+              </a:rPr>
+              <a:t/>
+            </a:r>
+          </a:p>
+          <a:p>
+            <a:r>
+              <a:rPr sz="1100">
+                <a:solidFill>
+                  <a:srgbClr val="A6E3A1"/>
+                </a:solidFill>
+                <a:latin typeface="Courier New"/>
+              </a:rPr>
+              <a:t>4. REASONING INSTRUCTIONS</a:t>
+            </a:r>
+          </a:p>
+          <a:p>
+            <a:r>
+              <a:rPr sz="1100">
+                <a:solidFill>
+                  <a:srgbClr val="A6E3A1"/>
+                </a:solidFill>
+                <a:latin typeface="Courier New"/>
+              </a:rPr>
+              <a:t>   "Name the specific words/phrases that drove your choice AND</a:t>
+            </a:r>
+          </a:p>
+          <a:p>
+            <a:r>
+              <a:rPr sz="1100">
+                <a:solidFill>
+                  <a:srgbClr val="A6E3A1"/>
+                </a:solidFill>
+                <a:latin typeface="Courier New"/>
+              </a:rPr>
+              <a:t>    explain why you ruled out the next-closest category." </a:t>
+            </a:r>
+          </a:p>
+        </p:txBody>
+      </p:sp>
+    </p:spTree>
+  </p:cSld>
+  <p:clrMapOvr>
+    <a:masterClrMapping/>
+  </p:clrMapOvr>
+</p:sld>
+</file>
+
+<file path=ppt/slides/slide28.xml><?xml version="1.0" encoding="utf-8"?>
+<p:sld xmlns:a="http://schemas.openxmlformats.org/drawingml/2006/main" xmlns:p="http://schemas.openxmlformats.org/presentationml/2006/main" xmlns:r="http://schemas.openxmlformats.org/officeDocument/2006/relationships">
+  <p:cSld>
+    <p:bg>
+      <p:bgPr>
+        <a:solidFill>
+          <a:srgbClr val="1E1E2E"/>
+        </a:solidFill>
+        <a:effectLst/>
+      </p:bgPr>
+    </p:bg>
+    <p:spTree>
+      <p:nvGrpSpPr>
+        <p:cNvPr id="1" name=""/>
+        <p:cNvGrpSpPr/>
+        <p:nvPr/>
+      </p:nvGrpSpPr>
+      <p:grpSpPr/>
+      <p:sp>
+        <p:nvSpPr>
+          <p:cNvPr id="2" name="TextBox 1"/>
+          <p:cNvSpPr txBox="1"/>
+          <p:nvPr/>
+        </p:nvSpPr>
+        <p:spPr>
+          <a:xfrm>
+            <a:off x="365760" y="228600"/>
+            <a:ext cx="8412480" cy="594360"/>
+          </a:xfrm>
+          <a:prstGeom prst="rect">
+            <a:avLst/>
+          </a:prstGeom>
+          <a:noFill/>
+        </p:spPr>
+        <p:txBody>
+          <a:bodyPr wrap="none">
+            <a:spAutoFit/>
+          </a:bodyPr>
+          <a:lstStyle/>
+          <a:p>
+            <a:pPr algn="l"/>
+            <a:r>
+              <a:rPr b="1" sz="2400">
+                <a:solidFill>
+                  <a:srgbClr val="74C7EC"/>
+                </a:solidFill>
+              </a:rPr>
+              <a:t>Summary of All Updates</a:t>
+            </a:r>
+          </a:p>
+        </p:txBody>
+      </p:sp>
+      <p:sp>
+        <p:nvSpPr>
+          <p:cNvPr id="3" name="Rectangle 2"/>
+          <p:cNvSpPr/>
+          <p:nvPr/>
+        </p:nvSpPr>
+        <p:spPr>
+          <a:xfrm>
+            <a:off x="320040" y="1005840"/>
+            <a:ext cx="320040" cy="347472"/>
+          </a:xfrm>
+          <a:prstGeom prst="rect">
+            <a:avLst/>
+          </a:prstGeom>
+          <a:solidFill>
+            <a:srgbClr val="74C7EC"/>
+          </a:solidFill>
+          <a:ln>
+            <a:noFill/>
+          </a:ln>
+        </p:spPr>
+        <p:style>
+          <a:lnRef idx="1">
+            <a:schemeClr val="accent1"/>
+          </a:lnRef>
+          <a:fillRef idx="3">
+            <a:schemeClr val="accent1"/>
+          </a:fillRef>
+          <a:effectRef idx="2">
+            <a:schemeClr val="accent1"/>
+          </a:effectRef>
+          <a:fontRef idx="minor">
+            <a:schemeClr val="lt1"/>
+          </a:fontRef>
+        </p:style>
+        <p:txBody>
+          <a:bodyPr rtlCol="0" anchor="ctr"/>
+          <a:lstStyle/>
+          <a:p>
+            <a:pPr algn="ctr"/>
+          </a:p>
+        </p:txBody>
+      </p:sp>
+      <p:sp>
+        <p:nvSpPr>
+          <p:cNvPr id="4" name="TextBox 3"/>
+          <p:cNvSpPr txBox="1"/>
+          <p:nvPr/>
+        </p:nvSpPr>
+        <p:spPr>
+          <a:xfrm>
+            <a:off x="320040" y="996696"/>
+            <a:ext cx="320040" cy="347472"/>
+          </a:xfrm>
+          <a:prstGeom prst="rect">
+            <a:avLst/>
+          </a:prstGeom>
+          <a:noFill/>
+        </p:spPr>
+        <p:txBody>
+          <a:bodyPr wrap="none">
+            <a:spAutoFit/>
+          </a:bodyPr>
+          <a:lstStyle/>
+          <a:p>
+            <a:pPr algn="ctr"/>
+            <a:r>
+              <a:rPr b="1" sz="1200">
+                <a:solidFill>
+                  <a:srgbClr val="1E1E2E"/>
+                </a:solidFill>
+              </a:rPr>
+              <a:t>1</a:t>
+            </a:r>
+          </a:p>
+        </p:txBody>
+      </p:sp>
+      <p:sp>
+        <p:nvSpPr>
+          <p:cNvPr id="5" name="TextBox 4"/>
+          <p:cNvSpPr txBox="1"/>
+          <p:nvPr/>
+        </p:nvSpPr>
+        <p:spPr>
+          <a:xfrm>
+            <a:off x="731520" y="960120"/>
+            <a:ext cx="1371600" cy="457200"/>
+          </a:xfrm>
+          <a:prstGeom prst="rect">
+            <a:avLst/>
+          </a:prstGeom>
+          <a:noFill/>
+        </p:spPr>
+        <p:txBody>
+          <a:bodyPr wrap="none">
+            <a:spAutoFit/>
+          </a:bodyPr>
+          <a:lstStyle/>
+          <a:p>
+            <a:r>
+              <a:rPr b="1" sz="1200">
+                <a:solidFill>
+                  <a:srgbClr val="F9E2AF"/>
+                </a:solidFill>
+              </a:rPr>
+              <a:t>main.py</a:t>
+            </a:r>
+          </a:p>
+        </p:txBody>
+      </p:sp>
+      <p:sp>
+        <p:nvSpPr>
+          <p:cNvPr id="6" name="TextBox 5"/>
+          <p:cNvSpPr txBox="1"/>
+          <p:nvPr/>
+        </p:nvSpPr>
+        <p:spPr>
+          <a:xfrm>
+            <a:off x="2194560" y="960120"/>
+            <a:ext cx="6400800" cy="457200"/>
+          </a:xfrm>
+          <a:prstGeom prst="rect">
+            <a:avLst/>
+          </a:prstGeom>
+          <a:noFill/>
+        </p:spPr>
+        <p:txBody>
+          <a:bodyPr wrap="none">
+            <a:spAutoFit/>
+          </a:bodyPr>
+          <a:lstStyle/>
+          <a:p>
+            <a:r>
+              <a:rPr sz="1200">
+                <a:solidFill>
+                  <a:srgbClr val="FFFFFF"/>
+                </a:solidFill>
+              </a:rPr>
+              <a:t>Numbered menu (1-6) + repeat-or-back sub-menu on every option</a:t>
+            </a:r>
+          </a:p>
+        </p:txBody>
+      </p:sp>
+      <p:sp>
+        <p:nvSpPr>
+          <p:cNvPr id="7" name="Rectangle 6"/>
+          <p:cNvSpPr/>
+          <p:nvPr/>
+        </p:nvSpPr>
+        <p:spPr>
+          <a:xfrm>
+            <a:off x="320040" y="1481328"/>
+            <a:ext cx="320040" cy="347472"/>
+          </a:xfrm>
+          <a:prstGeom prst="rect">
+            <a:avLst/>
+          </a:prstGeom>
+          <a:solidFill>
+            <a:srgbClr val="74C7EC"/>
+          </a:solidFill>
+          <a:ln>
+            <a:noFill/>
+          </a:ln>
+        </p:spPr>
+        <p:style>
+          <a:lnRef idx="1">
+            <a:schemeClr val="accent1"/>
+          </a:lnRef>
+          <a:fillRef idx="3">
+            <a:schemeClr val="accent1"/>
+          </a:fillRef>
+          <a:effectRef idx="2">
+            <a:schemeClr val="accent1"/>
+          </a:effectRef>
+          <a:fontRef idx="minor">
+            <a:schemeClr val="lt1"/>
+          </a:fontRef>
+        </p:style>
+        <p:txBody>
+          <a:bodyPr rtlCol="0" anchor="ctr"/>
+          <a:lstStyle/>
+          <a:p>
+            <a:pPr algn="ctr"/>
+          </a:p>
+        </p:txBody>
+      </p:sp>
+      <p:sp>
+        <p:nvSpPr>
+          <p:cNvPr id="8" name="TextBox 7"/>
+          <p:cNvSpPr txBox="1"/>
+          <p:nvPr/>
+        </p:nvSpPr>
+        <p:spPr>
+          <a:xfrm>
+            <a:off x="320040" y="1472184"/>
+            <a:ext cx="320040" cy="347472"/>
+          </a:xfrm>
+          <a:prstGeom prst="rect">
+            <a:avLst/>
+          </a:prstGeom>
+          <a:noFill/>
+        </p:spPr>
+        <p:txBody>
+          <a:bodyPr wrap="none">
+            <a:spAutoFit/>
+          </a:bodyPr>
+          <a:lstStyle/>
+          <a:p>
+            <a:pPr algn="ctr"/>
+            <a:r>
+              <a:rPr b="1" sz="1200">
+                <a:solidFill>
+                  <a:srgbClr val="1E1E2E"/>
+                </a:solidFill>
+              </a:rPr>
+              <a:t>2</a:t>
+            </a:r>
+          </a:p>
+        </p:txBody>
+      </p:sp>
+      <p:sp>
+        <p:nvSpPr>
+          <p:cNvPr id="9" name="TextBox 8"/>
+          <p:cNvSpPr txBox="1"/>
+          <p:nvPr/>
+        </p:nvSpPr>
+        <p:spPr>
+          <a:xfrm>
+            <a:off x="731520" y="1435608"/>
+            <a:ext cx="1371600" cy="457200"/>
+          </a:xfrm>
+          <a:prstGeom prst="rect">
+            <a:avLst/>
+          </a:prstGeom>
+          <a:noFill/>
+        </p:spPr>
+        <p:txBody>
+          <a:bodyPr wrap="none">
+            <a:spAutoFit/>
+          </a:bodyPr>
+          <a:lstStyle/>
+          <a:p>
+            <a:r>
+              <a:rPr b="1" sz="1200">
+                <a:solidFill>
+                  <a:srgbClr val="F9E2AF"/>
+                </a:solidFill>
+              </a:rPr>
+              <a:t>main.py</a:t>
+            </a:r>
+          </a:p>
+        </p:txBody>
+      </p:sp>
+      <p:sp>
+        <p:nvSpPr>
+          <p:cNvPr id="10" name="TextBox 9"/>
+          <p:cNvSpPr txBox="1"/>
+          <p:nvPr/>
+        </p:nvSpPr>
+        <p:spPr>
+          <a:xfrm>
+            <a:off x="2194560" y="1435608"/>
+            <a:ext cx="6400800" cy="457200"/>
+          </a:xfrm>
+          <a:prstGeom prst="rect">
+            <a:avLst/>
+          </a:prstGeom>
+          <a:noFill/>
+        </p:spPr>
+        <p:txBody>
+          <a:bodyPr wrap="none">
+            <a:spAutoFit/>
+          </a:bodyPr>
+          <a:lstStyle/>
+          <a:p>
+            <a:r>
+              <a:rPr sz="1200">
+                <a:solidFill>
+                  <a:srgbClr val="FFFFFF"/>
+                </a:solidFill>
+              </a:rPr>
+              <a:t>tkinter native file picker for Upload (Option 1)</a:t>
+            </a:r>
+          </a:p>
+        </p:txBody>
+      </p:sp>
+      <p:sp>
+        <p:nvSpPr>
+          <p:cNvPr id="11" name="Rectangle 10"/>
+          <p:cNvSpPr/>
+          <p:nvPr/>
+        </p:nvSpPr>
+        <p:spPr>
+          <a:xfrm>
+            <a:off x="320040" y="1956816"/>
+            <a:ext cx="320040" cy="347472"/>
+          </a:xfrm>
+          <a:prstGeom prst="rect">
+            <a:avLst/>
+          </a:prstGeom>
+          <a:solidFill>
+            <a:srgbClr val="74C7EC"/>
+          </a:solidFill>
+          <a:ln>
+            <a:noFill/>
+          </a:ln>
+        </p:spPr>
+        <p:style>
+          <a:lnRef idx="1">
+            <a:schemeClr val="accent1"/>
+          </a:lnRef>
+          <a:fillRef idx="3">
+            <a:schemeClr val="accent1"/>
+          </a:fillRef>
+          <a:effectRef idx="2">
+            <a:schemeClr val="accent1"/>
+          </a:effectRef>
+          <a:fontRef idx="minor">
+            <a:schemeClr val="lt1"/>
+          </a:fontRef>
+        </p:style>
+        <p:txBody>
+          <a:bodyPr rtlCol="0" anchor="ctr"/>
+          <a:lstStyle/>
+          <a:p>
+            <a:pPr algn="ctr"/>
+          </a:p>
+        </p:txBody>
+      </p:sp>
+      <p:sp>
+        <p:nvSpPr>
+          <p:cNvPr id="12" name="TextBox 11"/>
+          <p:cNvSpPr txBox="1"/>
+          <p:nvPr/>
+        </p:nvSpPr>
+        <p:spPr>
+          <a:xfrm>
+            <a:off x="320040" y="1947672"/>
+            <a:ext cx="320040" cy="347472"/>
+          </a:xfrm>
+          <a:prstGeom prst="rect">
+            <a:avLst/>
+          </a:prstGeom>
+          <a:noFill/>
+        </p:spPr>
+        <p:txBody>
+          <a:bodyPr wrap="none">
+            <a:spAutoFit/>
+          </a:bodyPr>
+          <a:lstStyle/>
+          <a:p>
+            <a:pPr algn="ctr"/>
+            <a:r>
+              <a:rPr b="1" sz="1200">
+                <a:solidFill>
+                  <a:srgbClr val="1E1E2E"/>
+                </a:solidFill>
+              </a:rPr>
+              <a:t>3</a:t>
+            </a:r>
+          </a:p>
+        </p:txBody>
+      </p:sp>
+      <p:sp>
+        <p:nvSpPr>
+          <p:cNvPr id="13" name="TextBox 12"/>
+          <p:cNvSpPr txBox="1"/>
+          <p:nvPr/>
+        </p:nvSpPr>
+        <p:spPr>
+          <a:xfrm>
+            <a:off x="731520" y="1911096"/>
+            <a:ext cx="1371600" cy="457200"/>
+          </a:xfrm>
+          <a:prstGeom prst="rect">
+            <a:avLst/>
+          </a:prstGeom>
+          <a:noFill/>
+        </p:spPr>
+        <p:txBody>
+          <a:bodyPr wrap="none">
+            <a:spAutoFit/>
+          </a:bodyPr>
+          <a:lstStyle/>
+          <a:p>
+            <a:r>
+              <a:rPr b="1" sz="1200">
+                <a:solidFill>
+                  <a:srgbClr val="F9E2AF"/>
+                </a:solidFill>
+              </a:rPr>
+              <a:t>tools.py</a:t>
+            </a:r>
+          </a:p>
+        </p:txBody>
+      </p:sp>
+      <p:sp>
+        <p:nvSpPr>
+          <p:cNvPr id="14" name="TextBox 13"/>
+          <p:cNvSpPr txBox="1"/>
+          <p:nvPr/>
+        </p:nvSpPr>
+        <p:spPr>
+          <a:xfrm>
+            <a:off x="2194560" y="1911096"/>
+            <a:ext cx="6400800" cy="457200"/>
+          </a:xfrm>
+          <a:prstGeom prst="rect">
+            <a:avLst/>
+          </a:prstGeom>
+          <a:noFill/>
+        </p:spPr>
+        <p:txBody>
+          <a:bodyPr wrap="none">
+            <a:spAutoFit/>
+          </a:bodyPr>
+          <a:lstStyle/>
+          <a:p>
+            <a:r>
+              <a:rPr sz="1200">
+                <a:solidFill>
+                  <a:srgbClr val="FFFFFF"/>
+                </a:solidFill>
+              </a:rPr>
+              <a:t>Per-session log files: logs/&lt;session_id&gt;.log</a:t>
+            </a:r>
+          </a:p>
+        </p:txBody>
+      </p:sp>
+      <p:sp>
+        <p:nvSpPr>
+          <p:cNvPr id="15" name="Rectangle 14"/>
+          <p:cNvSpPr/>
+          <p:nvPr/>
+        </p:nvSpPr>
+        <p:spPr>
+          <a:xfrm>
+            <a:off x="320040" y="2432304"/>
+            <a:ext cx="320040" cy="347472"/>
+          </a:xfrm>
+          <a:prstGeom prst="rect">
+            <a:avLst/>
+          </a:prstGeom>
+          <a:solidFill>
+            <a:srgbClr val="74C7EC"/>
+          </a:solidFill>
+          <a:ln>
+            <a:noFill/>
+          </a:ln>
+        </p:spPr>
+        <p:style>
+          <a:lnRef idx="1">
+            <a:schemeClr val="accent1"/>
+          </a:lnRef>
+          <a:fillRef idx="3">
+            <a:schemeClr val="accent1"/>
+          </a:fillRef>
+          <a:effectRef idx="2">
+            <a:schemeClr val="accent1"/>
+          </a:effectRef>
+          <a:fontRef idx="minor">
+            <a:schemeClr val="lt1"/>
+          </a:fontRef>
+        </p:style>
+        <p:txBody>
+          <a:bodyPr rtlCol="0" anchor="ctr"/>
+          <a:lstStyle/>
+          <a:p>
+            <a:pPr algn="ctr"/>
+          </a:p>
+        </p:txBody>
+      </p:sp>
+      <p:sp>
+        <p:nvSpPr>
+          <p:cNvPr id="16" name="TextBox 15"/>
+          <p:cNvSpPr txBox="1"/>
+          <p:nvPr/>
+        </p:nvSpPr>
+        <p:spPr>
+          <a:xfrm>
+            <a:off x="320040" y="2423160"/>
+            <a:ext cx="320040" cy="347472"/>
+          </a:xfrm>
+          <a:prstGeom prst="rect">
+            <a:avLst/>
+          </a:prstGeom>
+          <a:noFill/>
+        </p:spPr>
+        <p:txBody>
+          <a:bodyPr wrap="none">
+            <a:spAutoFit/>
+          </a:bodyPr>
+          <a:lstStyle/>
+          <a:p>
+            <a:pPr algn="ctr"/>
+            <a:r>
+              <a:rPr b="1" sz="1200">
+                <a:solidFill>
+                  <a:srgbClr val="1E1E2E"/>
+                </a:solidFill>
+              </a:rPr>
+              <a:t>4</a:t>
+            </a:r>
+          </a:p>
+        </p:txBody>
+      </p:sp>
+      <p:sp>
+        <p:nvSpPr>
+          <p:cNvPr id="17" name="TextBox 16"/>
+          <p:cNvSpPr txBox="1"/>
+          <p:nvPr/>
+        </p:nvSpPr>
+        <p:spPr>
+          <a:xfrm>
+            <a:off x="731520" y="2386584"/>
+            <a:ext cx="1371600" cy="457200"/>
+          </a:xfrm>
+          <a:prstGeom prst="rect">
+            <a:avLst/>
+          </a:prstGeom>
+          <a:noFill/>
+        </p:spPr>
+        <p:txBody>
+          <a:bodyPr wrap="none">
+            <a:spAutoFit/>
+          </a:bodyPr>
+          <a:lstStyle/>
+          <a:p>
+            <a:r>
+              <a:rPr b="1" sz="1200">
+                <a:solidFill>
+                  <a:srgbClr val="F9E2AF"/>
+                </a:solidFill>
+              </a:rPr>
+              <a:t>tools.py</a:t>
+            </a:r>
+          </a:p>
+        </p:txBody>
+      </p:sp>
+      <p:sp>
+        <p:nvSpPr>
+          <p:cNvPr id="18" name="TextBox 17"/>
+          <p:cNvSpPr txBox="1"/>
+          <p:nvPr/>
+        </p:nvSpPr>
+        <p:spPr>
+          <a:xfrm>
+            <a:off x="2194560" y="2386584"/>
+            <a:ext cx="6400800" cy="457200"/>
+          </a:xfrm>
+          <a:prstGeom prst="rect">
+            <a:avLst/>
+          </a:prstGeom>
+          <a:noFill/>
+        </p:spPr>
+        <p:txBody>
+          <a:bodyPr wrap="none">
+            <a:spAutoFit/>
+          </a:bodyPr>
+          <a:lstStyle/>
+          <a:p>
+            <a:r>
+              <a:rPr sz="1200">
+                <a:solidFill>
+                  <a:srgbClr val="FFFFFF"/>
+                </a:solidFill>
+              </a:rPr>
+              <a:t>All tool paths logged (LIST/EXACT/KEYWORD/FALLBACK/ERROR)</a:t>
+            </a:r>
+          </a:p>
+        </p:txBody>
+      </p:sp>
+      <p:sp>
+        <p:nvSpPr>
+          <p:cNvPr id="19" name="Rectangle 18"/>
+          <p:cNvSpPr/>
+          <p:nvPr/>
+        </p:nvSpPr>
+        <p:spPr>
+          <a:xfrm>
+            <a:off x="320040" y="2907792"/>
+            <a:ext cx="320040" cy="347472"/>
+          </a:xfrm>
+          <a:prstGeom prst="rect">
+            <a:avLst/>
+          </a:prstGeom>
+          <a:solidFill>
+            <a:srgbClr val="74C7EC"/>
+          </a:solidFill>
+          <a:ln>
+            <a:noFill/>
+          </a:ln>
+        </p:spPr>
+        <p:style>
+          <a:lnRef idx="1">
+            <a:schemeClr val="accent1"/>
+          </a:lnRef>
+          <a:fillRef idx="3">
+            <a:schemeClr val="accent1"/>
+          </a:fillRef>
+          <a:effectRef idx="2">
+            <a:schemeClr val="accent1"/>
+          </a:effectRef>
+          <a:fontRef idx="minor">
+            <a:schemeClr val="lt1"/>
+          </a:fontRef>
+        </p:style>
+        <p:txBody>
+          <a:bodyPr rtlCol="0" anchor="ctr"/>
+          <a:lstStyle/>
+          <a:p>
+            <a:pPr algn="ctr"/>
+          </a:p>
+        </p:txBody>
+      </p:sp>
+      <p:sp>
+        <p:nvSpPr>
+          <p:cNvPr id="20" name="TextBox 19"/>
+          <p:cNvSpPr txBox="1"/>
+          <p:nvPr/>
+        </p:nvSpPr>
+        <p:spPr>
+          <a:xfrm>
+            <a:off x="320040" y="2898648"/>
+            <a:ext cx="320040" cy="347472"/>
+          </a:xfrm>
+          <a:prstGeom prst="rect">
+            <a:avLst/>
+          </a:prstGeom>
+          <a:noFill/>
+        </p:spPr>
+        <p:txBody>
+          <a:bodyPr wrap="none">
+            <a:spAutoFit/>
+          </a:bodyPr>
+          <a:lstStyle/>
+          <a:p>
+            <a:pPr algn="ctr"/>
+            <a:r>
+              <a:rPr b="1" sz="1200">
+                <a:solidFill>
+                  <a:srgbClr val="1E1E2E"/>
+                </a:solidFill>
+              </a:rPr>
+              <a:t>5</a:t>
+            </a:r>
+          </a:p>
+        </p:txBody>
+      </p:sp>
+      <p:sp>
+        <p:nvSpPr>
+          <p:cNvPr id="21" name="TextBox 20"/>
+          <p:cNvSpPr txBox="1"/>
+          <p:nvPr/>
+        </p:nvSpPr>
+        <p:spPr>
+          <a:xfrm>
+            <a:off x="731520" y="2862072"/>
+            <a:ext cx="1371600" cy="457200"/>
+          </a:xfrm>
+          <a:prstGeom prst="rect">
+            <a:avLst/>
+          </a:prstGeom>
+          <a:noFill/>
+        </p:spPr>
+        <p:txBody>
+          <a:bodyPr wrap="none">
+            <a:spAutoFit/>
+          </a:bodyPr>
+          <a:lstStyle/>
+          <a:p>
+            <a:r>
+              <a:rPr b="1" sz="1200">
+                <a:solidFill>
+                  <a:srgbClr val="F9E2AF"/>
+                </a:solidFill>
+              </a:rPr>
+              <a:t>agent.py</a:t>
+            </a:r>
+          </a:p>
+        </p:txBody>
+      </p:sp>
+      <p:sp>
+        <p:nvSpPr>
+          <p:cNvPr id="22" name="TextBox 21"/>
+          <p:cNvSpPr txBox="1"/>
+          <p:nvPr/>
+        </p:nvSpPr>
+        <p:spPr>
+          <a:xfrm>
+            <a:off x="2194560" y="2862072"/>
+            <a:ext cx="6400800" cy="457200"/>
+          </a:xfrm>
+          <a:prstGeom prst="rect">
+            <a:avLst/>
+          </a:prstGeom>
+          <a:noFill/>
+        </p:spPr>
+        <p:txBody>
+          <a:bodyPr wrap="none">
+            <a:spAutoFit/>
+          </a:bodyPr>
+          <a:lstStyle/>
+          <a:p>
+            <a:r>
+              <a:rPr sz="1200">
+                <a:solidFill>
+                  <a:srgbClr val="FFFFFF"/>
+                </a:solidFill>
+              </a:rPr>
+              <a:t>_direct_retrieve() now logs its fallback calls</a:t>
+            </a:r>
+          </a:p>
+        </p:txBody>
+      </p:sp>
+      <p:sp>
+        <p:nvSpPr>
+          <p:cNvPr id="23" name="Rectangle 22"/>
+          <p:cNvSpPr/>
+          <p:nvPr/>
+        </p:nvSpPr>
+        <p:spPr>
+          <a:xfrm>
+            <a:off x="320040" y="3383280"/>
+            <a:ext cx="320040" cy="347472"/>
+          </a:xfrm>
+          <a:prstGeom prst="rect">
+            <a:avLst/>
+          </a:prstGeom>
+          <a:solidFill>
+            <a:srgbClr val="74C7EC"/>
+          </a:solidFill>
+          <a:ln>
+            <a:noFill/>
+          </a:ln>
+        </p:spPr>
+        <p:style>
+          <a:lnRef idx="1">
+            <a:schemeClr val="accent1"/>
+          </a:lnRef>
+          <a:fillRef idx="3">
+            <a:schemeClr val="accent1"/>
+          </a:fillRef>
+          <a:effectRef idx="2">
+            <a:schemeClr val="accent1"/>
+          </a:effectRef>
+          <a:fontRef idx="minor">
+            <a:schemeClr val="lt1"/>
+          </a:fontRef>
+        </p:style>
+        <p:txBody>
+          <a:bodyPr rtlCol="0" anchor="ctr"/>
+          <a:lstStyle/>
+          <a:p>
+            <a:pPr algn="ctr"/>
+          </a:p>
+        </p:txBody>
+      </p:sp>
+      <p:sp>
+        <p:nvSpPr>
+          <p:cNvPr id="24" name="TextBox 23"/>
+          <p:cNvSpPr txBox="1"/>
+          <p:nvPr/>
+        </p:nvSpPr>
+        <p:spPr>
+          <a:xfrm>
+            <a:off x="320040" y="3374136"/>
+            <a:ext cx="320040" cy="347472"/>
+          </a:xfrm>
+          <a:prstGeom prst="rect">
+            <a:avLst/>
+          </a:prstGeom>
+          <a:noFill/>
+        </p:spPr>
+        <p:txBody>
+          <a:bodyPr wrap="none">
+            <a:spAutoFit/>
+          </a:bodyPr>
+          <a:lstStyle/>
+          <a:p>
+            <a:pPr algn="ctr"/>
+            <a:r>
+              <a:rPr b="1" sz="1200">
+                <a:solidFill>
+                  <a:srgbClr val="1E1E2E"/>
+                </a:solidFill>
+              </a:rPr>
+              <a:t>6</a:t>
+            </a:r>
+          </a:p>
+        </p:txBody>
+      </p:sp>
+      <p:sp>
+        <p:nvSpPr>
+          <p:cNvPr id="25" name="TextBox 24"/>
+          <p:cNvSpPr txBox="1"/>
+          <p:nvPr/>
+        </p:nvSpPr>
+        <p:spPr>
+          <a:xfrm>
+            <a:off x="731520" y="3337560"/>
+            <a:ext cx="1371600" cy="457200"/>
+          </a:xfrm>
+          <a:prstGeom prst="rect">
+            <a:avLst/>
+          </a:prstGeom>
+          <a:noFill/>
+        </p:spPr>
+        <p:txBody>
+          <a:bodyPr wrap="none">
+            <a:spAutoFit/>
+          </a:bodyPr>
+          <a:lstStyle/>
+          <a:p>
+            <a:r>
+              <a:rPr b="1" sz="1200">
+                <a:solidFill>
+                  <a:srgbClr val="F9E2AF"/>
+                </a:solidFill>
+              </a:rPr>
+              <a:t>assistant.py</a:t>
+            </a:r>
+          </a:p>
+        </p:txBody>
+      </p:sp>
+      <p:sp>
+        <p:nvSpPr>
+          <p:cNvPr id="26" name="TextBox 25"/>
+          <p:cNvSpPr txBox="1"/>
+          <p:nvPr/>
+        </p:nvSpPr>
+        <p:spPr>
+          <a:xfrm>
+            <a:off x="2194560" y="3337560"/>
+            <a:ext cx="6400800" cy="457200"/>
+          </a:xfrm>
+          <a:prstGeom prst="rect">
+            <a:avLst/>
+          </a:prstGeom>
+          <a:noFill/>
+        </p:spPr>
+        <p:txBody>
+          <a:bodyPr wrap="none">
+            <a:spAutoFit/>
+          </a:bodyPr>
+          <a:lstStyle/>
+          <a:p>
+            <a:r>
+              <a:rPr sz="1200">
+                <a:solidFill>
+                  <a:srgbClr val="FFFFFF"/>
+                </a:solidFill>
+              </a:rPr>
+              <a:t>Full conversation history saved to sessions/&lt;uuid&gt;.json</a:t>
+            </a:r>
+          </a:p>
+        </p:txBody>
+      </p:sp>
+      <p:sp>
+        <p:nvSpPr>
+          <p:cNvPr id="27" name="Rectangle 26"/>
+          <p:cNvSpPr/>
+          <p:nvPr/>
+        </p:nvSpPr>
+        <p:spPr>
+          <a:xfrm>
+            <a:off x="320040" y="3858768"/>
+            <a:ext cx="320040" cy="347472"/>
+          </a:xfrm>
+          <a:prstGeom prst="rect">
+            <a:avLst/>
+          </a:prstGeom>
+          <a:solidFill>
+            <a:srgbClr val="74C7EC"/>
+          </a:solidFill>
+          <a:ln>
+            <a:noFill/>
+          </a:ln>
+        </p:spPr>
+        <p:style>
+          <a:lnRef idx="1">
+            <a:schemeClr val="accent1"/>
+          </a:lnRef>
+          <a:fillRef idx="3">
+            <a:schemeClr val="accent1"/>
+          </a:fillRef>
+          <a:effectRef idx="2">
+            <a:schemeClr val="accent1"/>
+          </a:effectRef>
+          <a:fontRef idx="minor">
+            <a:schemeClr val="lt1"/>
+          </a:fontRef>
+        </p:style>
+        <p:txBody>
+          <a:bodyPr rtlCol="0" anchor="ctr"/>
+          <a:lstStyle/>
+          <a:p>
+            <a:pPr algn="ctr"/>
+          </a:p>
+        </p:txBody>
+      </p:sp>
+      <p:sp>
+        <p:nvSpPr>
+          <p:cNvPr id="28" name="TextBox 27"/>
+          <p:cNvSpPr txBox="1"/>
+          <p:nvPr/>
+        </p:nvSpPr>
+        <p:spPr>
+          <a:xfrm>
+            <a:off x="320040" y="3849624"/>
+            <a:ext cx="320040" cy="347472"/>
+          </a:xfrm>
+          <a:prstGeom prst="rect">
+            <a:avLst/>
+          </a:prstGeom>
+          <a:noFill/>
+        </p:spPr>
+        <p:txBody>
+          <a:bodyPr wrap="none">
+            <a:spAutoFit/>
+          </a:bodyPr>
+          <a:lstStyle/>
+          <a:p>
+            <a:pPr algn="ctr"/>
+            <a:r>
+              <a:rPr b="1" sz="1200">
+                <a:solidFill>
+                  <a:srgbClr val="1E1E2E"/>
+                </a:solidFill>
+              </a:rPr>
+              <a:t>7</a:t>
+            </a:r>
+          </a:p>
+        </p:txBody>
+      </p:sp>
+      <p:sp>
+        <p:nvSpPr>
+          <p:cNvPr id="29" name="TextBox 28"/>
+          <p:cNvSpPr txBox="1"/>
+          <p:nvPr/>
+        </p:nvSpPr>
+        <p:spPr>
+          <a:xfrm>
+            <a:off x="731520" y="3813048"/>
+            <a:ext cx="1371600" cy="457200"/>
+          </a:xfrm>
+          <a:prstGeom prst="rect">
+            <a:avLst/>
+          </a:prstGeom>
+          <a:noFill/>
+        </p:spPr>
+        <p:txBody>
+          <a:bodyPr wrap="none">
+            <a:spAutoFit/>
+          </a:bodyPr>
+          <a:lstStyle/>
+          <a:p>
+            <a:r>
+              <a:rPr b="1" sz="1200">
+                <a:solidFill>
+                  <a:srgbClr val="F9E2AF"/>
+                </a:solidFill>
+              </a:rPr>
+              <a:t>prompts.py</a:t>
+            </a:r>
+          </a:p>
+        </p:txBody>
+      </p:sp>
+      <p:sp>
+        <p:nvSpPr>
+          <p:cNvPr id="30" name="TextBox 29"/>
+          <p:cNvSpPr txBox="1"/>
+          <p:nvPr/>
+        </p:nvSpPr>
+        <p:spPr>
+          <a:xfrm>
+            <a:off x="2194560" y="3813048"/>
+            <a:ext cx="6400800" cy="457200"/>
+          </a:xfrm>
+          <a:prstGeom prst="rect">
+            <a:avLst/>
+          </a:prstGeom>
+          <a:noFill/>
+        </p:spPr>
+        <p:txBody>
+          <a:bodyPr wrap="none">
+            <a:spAutoFit/>
+          </a:bodyPr>
+          <a:lstStyle/>
+          <a:p>
+            <a:r>
+              <a:rPr sz="1200">
+                <a:solidFill>
+                  <a:srgbClr val="FFFFFF"/>
+                </a:solidFill>
+              </a:rPr>
+              <a:t>MessagesPlaceholder added to all ChatPromptTemplates</a:t>
+            </a:r>
+          </a:p>
+        </p:txBody>
+      </p:sp>
+      <p:sp>
+        <p:nvSpPr>
+          <p:cNvPr id="31" name="Rectangle 30"/>
+          <p:cNvSpPr/>
+          <p:nvPr/>
+        </p:nvSpPr>
+        <p:spPr>
+          <a:xfrm>
+            <a:off x="320040" y="4334256"/>
+            <a:ext cx="320040" cy="347472"/>
+          </a:xfrm>
+          <a:prstGeom prst="rect">
+            <a:avLst/>
+          </a:prstGeom>
+          <a:solidFill>
+            <a:srgbClr val="74C7EC"/>
+          </a:solidFill>
+          <a:ln>
+            <a:noFill/>
+          </a:ln>
+        </p:spPr>
+        <p:style>
+          <a:lnRef idx="1">
+            <a:schemeClr val="accent1"/>
+          </a:lnRef>
+          <a:fillRef idx="3">
+            <a:schemeClr val="accent1"/>
+          </a:fillRef>
+          <a:effectRef idx="2">
+            <a:schemeClr val="accent1"/>
+          </a:effectRef>
+          <a:fontRef idx="minor">
+            <a:schemeClr val="lt1"/>
+          </a:fontRef>
+        </p:style>
+        <p:txBody>
+          <a:bodyPr rtlCol="0" anchor="ctr"/>
+          <a:lstStyle/>
+          <a:p>
+            <a:pPr algn="ctr"/>
+          </a:p>
+        </p:txBody>
+      </p:sp>
+      <p:sp>
+        <p:nvSpPr>
+          <p:cNvPr id="32" name="TextBox 31"/>
+          <p:cNvSpPr txBox="1"/>
+          <p:nvPr/>
+        </p:nvSpPr>
+        <p:spPr>
+          <a:xfrm>
+            <a:off x="320040" y="4325112"/>
+            <a:ext cx="320040" cy="347472"/>
+          </a:xfrm>
+          <a:prstGeom prst="rect">
+            <a:avLst/>
+          </a:prstGeom>
+          <a:noFill/>
+        </p:spPr>
+        <p:txBody>
+          <a:bodyPr wrap="none">
+            <a:spAutoFit/>
+          </a:bodyPr>
+          <a:lstStyle/>
+          <a:p>
+            <a:pPr algn="ctr"/>
+            <a:r>
+              <a:rPr b="1" sz="1200">
+                <a:solidFill>
+                  <a:srgbClr val="1E1E2E"/>
+                </a:solidFill>
+              </a:rPr>
+              <a:t>8</a:t>
+            </a:r>
+          </a:p>
+        </p:txBody>
+      </p:sp>
+      <p:sp>
+        <p:nvSpPr>
+          <p:cNvPr id="33" name="TextBox 32"/>
+          <p:cNvSpPr txBox="1"/>
+          <p:nvPr/>
+        </p:nvSpPr>
+        <p:spPr>
+          <a:xfrm>
+            <a:off x="731520" y="4288536"/>
+            <a:ext cx="1371600" cy="457200"/>
+          </a:xfrm>
+          <a:prstGeom prst="rect">
+            <a:avLst/>
+          </a:prstGeom>
+          <a:noFill/>
+        </p:spPr>
+        <p:txBody>
+          <a:bodyPr wrap="none">
+            <a:spAutoFit/>
+          </a:bodyPr>
+          <a:lstStyle/>
+          <a:p>
+            <a:r>
+              <a:rPr b="1" sz="1200">
+                <a:solidFill>
+                  <a:srgbClr val="F9E2AF"/>
+                </a:solidFill>
+              </a:rPr>
+              <a:t>prompts.py</a:t>
+            </a:r>
+          </a:p>
+        </p:txBody>
+      </p:sp>
+      <p:sp>
+        <p:nvSpPr>
+          <p:cNvPr id="34" name="TextBox 33"/>
+          <p:cNvSpPr txBox="1"/>
+          <p:nvPr/>
+        </p:nvSpPr>
+        <p:spPr>
+          <a:xfrm>
+            <a:off x="2194560" y="4288536"/>
+            <a:ext cx="6400800" cy="457200"/>
+          </a:xfrm>
+          <a:prstGeom prst="rect">
+            <a:avLst/>
+          </a:prstGeom>
+          <a:noFill/>
+        </p:spPr>
+        <p:txBody>
+          <a:bodyPr wrap="none">
+            <a:spAutoFit/>
+          </a:bodyPr>
+          <a:lstStyle/>
+          <a:p>
+            <a:r>
+              <a:rPr sz="1200">
+                <a:solidFill>
+                  <a:srgbClr val="FFFFFF"/>
+                </a:solidFill>
+              </a:rPr>
+              <a:t>Intent prompt: 3 examples/category, confidence guide, tie-breaking</a:t>
+            </a:r>
+          </a:p>
+        </p:txBody>
+      </p:sp>
+    </p:spTree>
+  </p:cSld>
+  <p:clrMapOvr>
+    <a:masterClrMapping/>
+  </p:clrMapOvr>
+</p:sld>
+</file>
+
 <file path=ppt/slides/slide3.xml><?xml version="1.0" encoding="utf-8"?>
 <p:sld xmlns:a="http://schemas.openxmlformats.org/drawingml/2006/main" xmlns:r="http://schemas.openxmlformats.org/officeDocument/2006/relationships" xmlns:p="http://schemas.openxmlformats.org/presentationml/2006/main">
   <p:cSld name="Slide 3">

</xml_diff>